<commit_message>
Single-column poster: larger fonts and boxed section titles
Co-Authored-By: Claude Opus 5.5 <noreply@anthropic.com>
Claude-Session: https://claude.ai/code/session_01MfhLusbbFu3z4J6aTCZXt3
</commit_message>
<xml_diff>
--- a/poster/IHPBA2026_RDP_ePoster_single_column.pptx
+++ b/poster/IHPBA2026_RDP_ePoster_single_column.pptx
@@ -6032,7 +6032,7 @@
         <p:spPr>
           <a:xfrm>
             <a:off x="685800" y="4270248"/>
-            <a:ext cx="2304288" cy="1097280"/>
+            <a:ext cx="2304288" cy="1078992"/>
           </a:xfrm>
           <a:prstGeom prst="roundRect">
             <a:avLst>
@@ -6062,7 +6062,7 @@
               <a:buNone/>
             </a:pPr>
             <a:r>
-              <a:rPr lang="en-US" sz="2800" b="1" dirty="0">
+              <a:rPr lang="en-US" sz="3200" b="1" dirty="0">
                 <a:solidFill>
                   <a:srgbClr val="213C80"/>
                 </a:solidFill>
@@ -6081,7 +6081,7 @@
               <a:buNone/>
             </a:pPr>
             <a:r>
-              <a:rPr lang="en-US" sz="1150" dirty="0">
+              <a:rPr lang="en-US" sz="1300" dirty="0">
                 <a:solidFill>
                   <a:srgbClr val="1F2937"/>
                 </a:solidFill>
@@ -6100,7 +6100,7 @@
         <p:spPr>
           <a:xfrm>
             <a:off x="3172968" y="4270248"/>
-            <a:ext cx="2304288" cy="1097280"/>
+            <a:ext cx="2304288" cy="1078992"/>
           </a:xfrm>
           <a:prstGeom prst="roundRect">
             <a:avLst>
@@ -6130,7 +6130,7 @@
               <a:buNone/>
             </a:pPr>
             <a:r>
-              <a:rPr lang="en-US" sz="2800" b="1" dirty="0">
+              <a:rPr lang="en-US" sz="3200" b="1" dirty="0">
                 <a:solidFill>
                   <a:srgbClr val="213C80"/>
                 </a:solidFill>
@@ -6149,7 +6149,7 @@
               <a:buNone/>
             </a:pPr>
             <a:r>
-              <a:rPr lang="en-US" sz="1150" dirty="0">
+              <a:rPr lang="en-US" sz="1300" dirty="0">
                 <a:solidFill>
                   <a:srgbClr val="1F2937"/>
                 </a:solidFill>
@@ -6168,7 +6168,7 @@
         <p:spPr>
           <a:xfrm>
             <a:off x="5660136" y="4270248"/>
-            <a:ext cx="2304288" cy="1097280"/>
+            <a:ext cx="2304288" cy="1078992"/>
           </a:xfrm>
           <a:prstGeom prst="roundRect">
             <a:avLst>
@@ -6198,7 +6198,7 @@
               <a:buNone/>
             </a:pPr>
             <a:r>
-              <a:rPr lang="en-US" sz="2800" b="1" dirty="0">
+              <a:rPr lang="en-US" sz="3200" b="1" dirty="0">
                 <a:solidFill>
                   <a:srgbClr val="213C80"/>
                 </a:solidFill>
@@ -6217,7 +6217,7 @@
               <a:buNone/>
             </a:pPr>
             <a:r>
-              <a:rPr lang="en-US" sz="1150" dirty="0">
+              <a:rPr lang="en-US" sz="1300" dirty="0">
                 <a:solidFill>
                   <a:srgbClr val="1F2937"/>
                 </a:solidFill>
@@ -6236,7 +6236,7 @@
         <p:spPr>
           <a:xfrm>
             <a:off x="8147304" y="4270248"/>
-            <a:ext cx="2304288" cy="1097280"/>
+            <a:ext cx="2304288" cy="1078992"/>
           </a:xfrm>
           <a:prstGeom prst="roundRect">
             <a:avLst>
@@ -6266,7 +6266,7 @@
               <a:buNone/>
             </a:pPr>
             <a:r>
-              <a:rPr lang="en-US" sz="2800" b="1" dirty="0">
+              <a:rPr lang="en-US" sz="3200" b="1" dirty="0">
                 <a:solidFill>
                   <a:srgbClr val="BB890B"/>
                 </a:solidFill>
@@ -6285,26 +6285,71 @@
               <a:buNone/>
             </a:pPr>
             <a:r>
-              <a:rPr lang="en-US" sz="1150" dirty="0">
+              <a:rPr lang="en-US" sz="1300" dirty="0">
                 <a:solidFill>
                   <a:srgbClr val="1F2937"/>
                 </a:solidFill>
               </a:rPr>
-              <a:t>operating time vs laparoscopic, mostly docking</a:t>
+              <a:t>operating time vs laparoscopic</a:t>
             </a:r>
           </a:p>
         </p:txBody>
       </p:sp>
       <p:sp>
         <p:nvSpPr>
-          <p:cNvPr id="109" name="Section 1 number"/>
+          <p:cNvPr id="109" name="Section 1 title bar"/>
           <p:cNvSpPr txBox="1"/>
           <p:nvPr/>
         </p:nvSpPr>
         <p:spPr>
           <a:xfrm>
-            <a:off x="685800" y="5641848"/>
-            <a:ext cx="420624" cy="420624"/>
+            <a:off x="685800" y="5568696"/>
+            <a:ext cx="4677156" cy="512064"/>
+          </a:xfrm>
+          <a:prstGeom prst="roundRect">
+            <a:avLst>
+              <a:gd name="adj" fmla="val 18000"/>
+            </a:avLst>
+          </a:prstGeom>
+          <a:solidFill>
+            <a:srgbClr val="213C80"/>
+          </a:solidFill>
+          <a:ln>
+            <a:noFill/>
+          </a:ln>
+        </p:spPr>
+        <p:txBody>
+          <a:bodyPr wrap="square" lIns="0" tIns="0" rIns="0" bIns="0" anchor="t">
+            <a:noAutofit/>
+          </a:bodyPr>
+          <a:lstStyle/>
+          <a:p>
+            <a:pPr marL="0" indent="0">
+              <a:spcBef>
+                <a:spcPts val="0"/>
+              </a:spcBef>
+              <a:spcAft>
+                <a:spcPts val="0"/>
+              </a:spcAft>
+              <a:buNone/>
+            </a:pPr>
+            <a:r>
+              <a:rPr lang="en-US" dirty="0"/>
+              <a:t/>
+            </a:r>
+          </a:p>
+        </p:txBody>
+      </p:sp>
+      <p:sp>
+        <p:nvSpPr>
+          <p:cNvPr id="110" name="Section 1 number"/>
+          <p:cNvSpPr txBox="1"/>
+          <p:nvPr/>
+        </p:nvSpPr>
+        <p:spPr>
+          <a:xfrm>
+            <a:off x="777240" y="5632704"/>
+            <a:ext cx="384048" cy="384048"/>
           </a:xfrm>
           <a:prstGeom prst="ellipse">
             <a:avLst/>
@@ -6332,9 +6377,9 @@
               <a:buNone/>
             </a:pPr>
             <a:r>
-              <a:rPr lang="en-US" sz="1200" b="1" dirty="0">
-                <a:solidFill>
-                  <a:srgbClr val="FFFFFF"/>
+              <a:rPr lang="en-US" sz="1250" b="1" dirty="0">
+                <a:solidFill>
+                  <a:srgbClr val="213C80"/>
                 </a:solidFill>
               </a:rPr>
               <a:t>01</a:t>
@@ -6344,14 +6389,14 @@
       </p:sp>
       <p:sp>
         <p:nvSpPr>
-          <p:cNvPr id="110" name="Section 1 title"/>
+          <p:cNvPr id="111" name="Section 1 title"/>
           <p:cNvSpPr txBox="1"/>
           <p:nvPr/>
         </p:nvSpPr>
         <p:spPr>
           <a:xfrm>
-            <a:off x="1234440" y="5641848"/>
-            <a:ext cx="4128516" cy="420624"/>
+            <a:off x="1289304" y="5568696"/>
+            <a:ext cx="3982212" cy="512064"/>
           </a:xfrm>
           <a:prstGeom prst="rect">
             <a:avLst/>
@@ -6379,24 +6424,24 @@
             <a:r>
               <a:rPr lang="en-US" sz="1800" b="1" dirty="0">
                 <a:solidFill>
-                  <a:srgbClr val="213C80"/>
-                </a:solidFill>
-              </a:rPr>
-              <a:t>Background &amp; aim</a:t>
+                  <a:srgbClr val="FFFFFF"/>
+                </a:solidFill>
+              </a:rPr>
+              <a:t>BACKGROUND &amp; AIM</a:t>
             </a:r>
           </a:p>
         </p:txBody>
       </p:sp>
       <p:sp>
         <p:nvSpPr>
-          <p:cNvPr id="111" name="Background"/>
+          <p:cNvPr id="112" name="Background"/>
           <p:cNvSpPr txBox="1"/>
           <p:nvPr/>
         </p:nvSpPr>
         <p:spPr>
           <a:xfrm>
-            <a:off x="685800" y="6153912"/>
-            <a:ext cx="4677156" cy="1097280"/>
+            <a:off x="685800" y="6172200"/>
+            <a:ext cx="4677156" cy="1005840"/>
           </a:xfrm>
           <a:prstGeom prst="rect">
             <a:avLst/>
@@ -6426,8 +6471,8 @@
               <a:buChar char="•"/>
             </a:pPr>
             <a:r>
-              <a:rPr lang="en-US" sz="1250" dirty="0"/>
-              <a:t>Distal pancreatectomy has moved from open (ODP) to laparoscopic (LDP) and robotic (RDP) surgery.</a:t>
+              <a:rPr lang="en-US" sz="1400" dirty="0"/>
+              <a:t>Open (ODP) → laparoscopic (LDP) → robotic (RDP)</a:t>
             </a:r>
           </a:p>
           <a:p>
@@ -6445,8 +6490,8 @@
               <a:buChar char="•"/>
             </a:pPr>
             <a:r>
-              <a:rPr lang="en-US" sz="1250" dirty="0"/>
-              <a:t>LDP is limited by dexterity and visualisation.</a:t>
+              <a:rPr lang="en-US" sz="1400" dirty="0"/>
+              <a:t>LDP is limited by dexterity and visualisation</a:t>
             </a:r>
           </a:p>
           <a:p>
@@ -6464,22 +6509,22 @@
               <a:buChar char="•"/>
             </a:pPr>
             <a:r>
-              <a:rPr lang="en-US" sz="1250" dirty="0"/>
-              <a:t>Whether RDP's technical gains improve outcomes is still debated.</a:t>
+              <a:rPr lang="en-US" sz="1400" dirty="0"/>
+              <a:t>Whether RDP improves outcomes is debated</a:t>
             </a:r>
           </a:p>
         </p:txBody>
       </p:sp>
       <p:sp>
         <p:nvSpPr>
-          <p:cNvPr id="112" name="Aim"/>
+          <p:cNvPr id="113" name="Aim"/>
           <p:cNvSpPr txBox="1"/>
           <p:nvPr/>
         </p:nvSpPr>
         <p:spPr>
           <a:xfrm>
-            <a:off x="685800" y="7287768"/>
-            <a:ext cx="4677156" cy="749808"/>
+            <a:off x="685800" y="7251192"/>
+            <a:ext cx="4677156" cy="877824"/>
           </a:xfrm>
           <a:prstGeom prst="roundRect">
             <a:avLst>
@@ -6509,30 +6554,75 @@
               <a:buNone/>
             </a:pPr>
             <a:r>
-              <a:rPr lang="en-US" sz="1250" b="1" dirty="0">
+              <a:rPr lang="en-US" sz="1400" b="1" dirty="0">
                 <a:solidFill>
                   <a:srgbClr val="BB890B"/>
                 </a:solidFill>
               </a:rPr>
-              <a:t xml:space="preserve">Aim  </a:t>
-            </a:r>
-            <a:r>
-              <a:rPr lang="en-US" sz="1250" dirty="0"/>
-              <a:t>Compare RDP with ODP and LDP: technique, outcomes, cost and challenges.</a:t>
+              <a:t xml:space="preserve">AIM  </a:t>
+            </a:r>
+            <a:r>
+              <a:rPr lang="en-US" sz="1400" dirty="0"/>
+              <a:t>Compare RDP with ODP and LDP: technique, outcomes, cost, challenges</a:t>
             </a:r>
           </a:p>
         </p:txBody>
       </p:sp>
       <p:sp>
         <p:nvSpPr>
-          <p:cNvPr id="113" name="Section 2 number"/>
+          <p:cNvPr id="114" name="Section 2 title bar"/>
           <p:cNvSpPr txBox="1"/>
           <p:nvPr/>
         </p:nvSpPr>
         <p:spPr>
           <a:xfrm>
-            <a:off x="5774436" y="5641848"/>
-            <a:ext cx="420624" cy="420624"/>
+            <a:off x="5774436" y="5568696"/>
+            <a:ext cx="4677156" cy="512064"/>
+          </a:xfrm>
+          <a:prstGeom prst="roundRect">
+            <a:avLst>
+              <a:gd name="adj" fmla="val 18000"/>
+            </a:avLst>
+          </a:prstGeom>
+          <a:solidFill>
+            <a:srgbClr val="213C80"/>
+          </a:solidFill>
+          <a:ln>
+            <a:noFill/>
+          </a:ln>
+        </p:spPr>
+        <p:txBody>
+          <a:bodyPr wrap="square" lIns="0" tIns="0" rIns="0" bIns="0" anchor="t">
+            <a:noAutofit/>
+          </a:bodyPr>
+          <a:lstStyle/>
+          <a:p>
+            <a:pPr marL="0" indent="0">
+              <a:spcBef>
+                <a:spcPts val="0"/>
+              </a:spcBef>
+              <a:spcAft>
+                <a:spcPts val="0"/>
+              </a:spcAft>
+              <a:buNone/>
+            </a:pPr>
+            <a:r>
+              <a:rPr lang="en-US" dirty="0"/>
+              <a:t/>
+            </a:r>
+          </a:p>
+        </p:txBody>
+      </p:sp>
+      <p:sp>
+        <p:nvSpPr>
+          <p:cNvPr id="115" name="Section 2 number"/>
+          <p:cNvSpPr txBox="1"/>
+          <p:nvPr/>
+        </p:nvSpPr>
+        <p:spPr>
+          <a:xfrm>
+            <a:off x="5865876" y="5632704"/>
+            <a:ext cx="384048" cy="384048"/>
           </a:xfrm>
           <a:prstGeom prst="ellipse">
             <a:avLst/>
@@ -6560,9 +6650,9 @@
               <a:buNone/>
             </a:pPr>
             <a:r>
-              <a:rPr lang="en-US" sz="1200" b="1" dirty="0">
-                <a:solidFill>
-                  <a:srgbClr val="FFFFFF"/>
+              <a:rPr lang="en-US" sz="1250" b="1" dirty="0">
+                <a:solidFill>
+                  <a:srgbClr val="213C80"/>
                 </a:solidFill>
               </a:rPr>
               <a:t>02</a:t>
@@ -6572,14 +6662,14 @@
       </p:sp>
       <p:sp>
         <p:nvSpPr>
-          <p:cNvPr id="114" name="Section 2 title"/>
+          <p:cNvPr id="116" name="Section 2 title"/>
           <p:cNvSpPr txBox="1"/>
           <p:nvPr/>
         </p:nvSpPr>
         <p:spPr>
           <a:xfrm>
-            <a:off x="6323076" y="5641848"/>
-            <a:ext cx="4128516" cy="420624"/>
+            <a:off x="6377940" y="5568696"/>
+            <a:ext cx="3982212" cy="512064"/>
           </a:xfrm>
           <a:prstGeom prst="rect">
             <a:avLst/>
@@ -6607,23 +6697,23 @@
             <a:r>
               <a:rPr lang="en-US" sz="1800" b="1" dirty="0">
                 <a:solidFill>
-                  <a:srgbClr val="213C80"/>
-                </a:solidFill>
-              </a:rPr>
-              <a:t>Why robotic?</a:t>
+                  <a:srgbClr val="FFFFFF"/>
+                </a:solidFill>
+              </a:rPr>
+              <a:t>WHY ROBOTIC?</a:t>
             </a:r>
           </a:p>
         </p:txBody>
       </p:sp>
       <p:sp>
         <p:nvSpPr>
-          <p:cNvPr id="115" name="Advantage circle 3D magnified"/>
+          <p:cNvPr id="117" name="Advantage circle 3D magnified"/>
           <p:cNvSpPr txBox="1"/>
           <p:nvPr/>
         </p:nvSpPr>
         <p:spPr>
           <a:xfrm>
-            <a:off x="5977318" y="6199632"/>
+            <a:off x="5977318" y="6217920"/>
             <a:ext cx="694944" cy="694944"/>
           </a:xfrm>
           <a:prstGeom prst="ellipse">
@@ -6660,7 +6750,7 @@
       </p:sp>
       <p:pic>
         <p:nvPicPr>
-          <p:cNvPr id="116" name="Icon 3D magnified" descr="3D magnified vision"/>
+          <p:cNvPr id="118" name="Icon 3D magnified" descr="3D magnified vision"/>
           <p:cNvPicPr>
             <a:picLocks noChangeAspect="1"/>
           </p:cNvPicPr>
@@ -6674,7 +6764,7 @@
         </p:blipFill>
         <p:spPr>
           <a:xfrm>
-            <a:off x="6132766" y="6391656"/>
+            <a:off x="6132766" y="6409944"/>
             <a:ext cx="384048" cy="384048"/>
           </a:xfrm>
           <a:prstGeom prst="rect">
@@ -6684,14 +6774,14 @@
       </p:pic>
       <p:sp>
         <p:nvSpPr>
-          <p:cNvPr id="117" name="Advantage 3D magnified"/>
+          <p:cNvPr id="119" name="Advantage 3D magnified"/>
           <p:cNvSpPr txBox="1"/>
           <p:nvPr/>
         </p:nvSpPr>
         <p:spPr>
           <a:xfrm>
-            <a:off x="5728716" y="6976872"/>
-            <a:ext cx="1192149" cy="502920"/>
+            <a:off x="5701284" y="6995160"/>
+            <a:ext cx="1247013" cy="566928"/>
           </a:xfrm>
           <a:prstGeom prst="rect">
             <a:avLst/>
@@ -6717,7 +6807,7 @@
               <a:buNone/>
             </a:pPr>
             <a:r>
-              <a:rPr lang="en-US" sz="1100" b="1" dirty="0">
+              <a:rPr lang="en-US" sz="1300" b="1" dirty="0">
                 <a:solidFill>
                   <a:srgbClr val="213C80"/>
                 </a:solidFill>
@@ -6736,7 +6826,7 @@
               <a:buNone/>
             </a:pPr>
             <a:r>
-              <a:rPr lang="en-US" sz="1100" dirty="0">
+              <a:rPr lang="en-US" sz="1300" dirty="0">
                 <a:solidFill>
                   <a:srgbClr val="1F2937"/>
                 </a:solidFill>
@@ -6748,13 +6838,13 @@
       </p:sp>
       <p:sp>
         <p:nvSpPr>
-          <p:cNvPr id="118" name="Advantage circle Tremor"/>
+          <p:cNvPr id="120" name="Advantage circle Tremor"/>
           <p:cNvSpPr txBox="1"/>
           <p:nvPr/>
         </p:nvSpPr>
         <p:spPr>
           <a:xfrm>
-            <a:off x="7169468" y="6199632"/>
+            <a:off x="7169468" y="6217920"/>
             <a:ext cx="694944" cy="694944"/>
           </a:xfrm>
           <a:prstGeom prst="ellipse">
@@ -6791,7 +6881,7 @@
       </p:sp>
       <p:pic>
         <p:nvPicPr>
-          <p:cNvPr id="119" name="Icon Tremor" descr="Tremor filtration"/>
+          <p:cNvPr id="121" name="Icon Tremor" descr="Tremor filtration"/>
           <p:cNvPicPr>
             <a:picLocks noChangeAspect="1"/>
           </p:cNvPicPr>
@@ -6805,7 +6895,7 @@
         </p:blipFill>
         <p:spPr>
           <a:xfrm>
-            <a:off x="7324915" y="6391656"/>
+            <a:off x="7324915" y="6409944"/>
             <a:ext cx="384048" cy="384048"/>
           </a:xfrm>
           <a:prstGeom prst="rect">
@@ -6815,14 +6905,14 @@
       </p:pic>
       <p:sp>
         <p:nvSpPr>
-          <p:cNvPr id="120" name="Advantage Tremor"/>
+          <p:cNvPr id="122" name="Advantage Tremor"/>
           <p:cNvSpPr txBox="1"/>
           <p:nvPr/>
         </p:nvSpPr>
         <p:spPr>
           <a:xfrm>
-            <a:off x="6920865" y="6976872"/>
-            <a:ext cx="1192149" cy="502920"/>
+            <a:off x="6893433" y="6995160"/>
+            <a:ext cx="1247013" cy="566928"/>
           </a:xfrm>
           <a:prstGeom prst="rect">
             <a:avLst/>
@@ -6848,7 +6938,7 @@
               <a:buNone/>
             </a:pPr>
             <a:r>
-              <a:rPr lang="en-US" sz="1100" b="1" dirty="0">
+              <a:rPr lang="en-US" sz="1300" b="1" dirty="0">
                 <a:solidFill>
                   <a:srgbClr val="213C80"/>
                 </a:solidFill>
@@ -6867,7 +6957,7 @@
               <a:buNone/>
             </a:pPr>
             <a:r>
-              <a:rPr lang="en-US" sz="1100" dirty="0">
+              <a:rPr lang="en-US" sz="1300" dirty="0">
                 <a:solidFill>
                   <a:srgbClr val="1F2937"/>
                 </a:solidFill>
@@ -6879,13 +6969,13 @@
       </p:sp>
       <p:sp>
         <p:nvSpPr>
-          <p:cNvPr id="121" name="Advantage circle Motion"/>
+          <p:cNvPr id="123" name="Advantage circle Motion"/>
           <p:cNvSpPr txBox="1"/>
           <p:nvPr/>
         </p:nvSpPr>
         <p:spPr>
           <a:xfrm>
-            <a:off x="8361616" y="6199632"/>
+            <a:off x="8361616" y="6217920"/>
             <a:ext cx="694944" cy="694944"/>
           </a:xfrm>
           <a:prstGeom prst="ellipse">
@@ -6922,7 +7012,7 @@
       </p:sp>
       <p:pic>
         <p:nvPicPr>
-          <p:cNvPr id="122" name="Icon Motion" descr="Motion scaling"/>
+          <p:cNvPr id="124" name="Icon Motion" descr="Motion scaling"/>
           <p:cNvPicPr>
             <a:picLocks noChangeAspect="1"/>
           </p:cNvPicPr>
@@ -6936,7 +7026,7 @@
         </p:blipFill>
         <p:spPr>
           <a:xfrm>
-            <a:off x="8517064" y="6391656"/>
+            <a:off x="8517064" y="6409944"/>
             <a:ext cx="384048" cy="384048"/>
           </a:xfrm>
           <a:prstGeom prst="rect">
@@ -6946,14 +7036,14 @@
       </p:pic>
       <p:sp>
         <p:nvSpPr>
-          <p:cNvPr id="123" name="Advantage Motion"/>
+          <p:cNvPr id="125" name="Advantage Motion"/>
           <p:cNvSpPr txBox="1"/>
           <p:nvPr/>
         </p:nvSpPr>
         <p:spPr>
           <a:xfrm>
-            <a:off x="8113014" y="6976872"/>
-            <a:ext cx="1192149" cy="502920"/>
+            <a:off x="8085582" y="6995160"/>
+            <a:ext cx="1247013" cy="566928"/>
           </a:xfrm>
           <a:prstGeom prst="rect">
             <a:avLst/>
@@ -6979,7 +7069,7 @@
               <a:buNone/>
             </a:pPr>
             <a:r>
-              <a:rPr lang="en-US" sz="1100" b="1" dirty="0">
+              <a:rPr lang="en-US" sz="1300" b="1" dirty="0">
                 <a:solidFill>
                   <a:srgbClr val="213C80"/>
                 </a:solidFill>
@@ -6998,7 +7088,7 @@
               <a:buNone/>
             </a:pPr>
             <a:r>
-              <a:rPr lang="en-US" sz="1100" dirty="0">
+              <a:rPr lang="en-US" sz="1300" dirty="0">
                 <a:solidFill>
                   <a:srgbClr val="1F2937"/>
                 </a:solidFill>
@@ -7010,13 +7100,13 @@
       </p:sp>
       <p:sp>
         <p:nvSpPr>
-          <p:cNvPr id="124" name="Advantage circle Wristed"/>
+          <p:cNvPr id="126" name="Advantage circle Wristed"/>
           <p:cNvSpPr txBox="1"/>
           <p:nvPr/>
         </p:nvSpPr>
         <p:spPr>
           <a:xfrm>
-            <a:off x="9553766" y="6199632"/>
+            <a:off x="9553766" y="6217920"/>
             <a:ext cx="694944" cy="694944"/>
           </a:xfrm>
           <a:prstGeom prst="ellipse">
@@ -7053,7 +7143,7 @@
       </p:sp>
       <p:pic>
         <p:nvPicPr>
-          <p:cNvPr id="125" name="Icon Wristed" descr="Wristed instruments"/>
+          <p:cNvPr id="127" name="Icon Wristed" descr="Wristed instruments"/>
           <p:cNvPicPr>
             <a:picLocks noChangeAspect="1"/>
           </p:cNvPicPr>
@@ -7067,7 +7157,7 @@
         </p:blipFill>
         <p:spPr>
           <a:xfrm>
-            <a:off x="9709214" y="6391656"/>
+            <a:off x="9709214" y="6409944"/>
             <a:ext cx="384048" cy="384048"/>
           </a:xfrm>
           <a:prstGeom prst="rect">
@@ -7077,14 +7167,14 @@
       </p:pic>
       <p:sp>
         <p:nvSpPr>
-          <p:cNvPr id="126" name="Advantage Wristed"/>
+          <p:cNvPr id="128" name="Advantage Wristed"/>
           <p:cNvSpPr txBox="1"/>
           <p:nvPr/>
         </p:nvSpPr>
         <p:spPr>
           <a:xfrm>
-            <a:off x="9305163" y="6976872"/>
-            <a:ext cx="1192149" cy="502920"/>
+            <a:off x="9277731" y="6995160"/>
+            <a:ext cx="1247013" cy="566928"/>
           </a:xfrm>
           <a:prstGeom prst="rect">
             <a:avLst/>
@@ -7110,7 +7200,7 @@
               <a:buNone/>
             </a:pPr>
             <a:r>
-              <a:rPr lang="en-US" sz="1100" b="1" dirty="0">
+              <a:rPr lang="en-US" sz="1300" b="1" dirty="0">
                 <a:solidFill>
                   <a:srgbClr val="213C80"/>
                 </a:solidFill>
@@ -7129,7 +7219,7 @@
               <a:buNone/>
             </a:pPr>
             <a:r>
-              <a:rPr lang="en-US" sz="1100" dirty="0">
+              <a:rPr lang="en-US" sz="1300" dirty="0">
                 <a:solidFill>
                   <a:srgbClr val="1F2937"/>
                 </a:solidFill>
@@ -7141,14 +7231,14 @@
       </p:sp>
       <p:sp>
         <p:nvSpPr>
-          <p:cNvPr id="127" name="Platforms note"/>
+          <p:cNvPr id="129" name="Platforms note"/>
           <p:cNvSpPr txBox="1"/>
           <p:nvPr/>
         </p:nvSpPr>
         <p:spPr>
           <a:xfrm>
-            <a:off x="5774436" y="7525512"/>
-            <a:ext cx="4677156" cy="502920"/>
+            <a:off x="5774436" y="7616952"/>
+            <a:ext cx="4677156" cy="548640"/>
           </a:xfrm>
           <a:prstGeom prst="rect">
             <a:avLst/>
@@ -7174,7 +7264,7 @@
               <a:buNone/>
             </a:pPr>
             <a:r>
-              <a:rPr lang="en-US" sz="1150" b="1" dirty="0">
+              <a:rPr lang="en-US" sz="1300" b="1" dirty="0">
                 <a:solidFill>
                   <a:srgbClr val="213C80"/>
                 </a:solidFill>
@@ -7182,26 +7272,71 @@
               <a:t xml:space="preserve">Platforms: </a:t>
             </a:r>
             <a:r>
-              <a:rPr lang="en-US" sz="1150" dirty="0">
+              <a:rPr lang="en-US" sz="1300" dirty="0">
                 <a:solidFill>
                   <a:srgbClr val="5B6472"/>
                 </a:solidFill>
               </a:rPr>
-              <a:t>almost all evidence is from da Vinci; Versius and hinotori™ have only early case reports.</a:t>
+              <a:t>evidence is mostly da Vinci; Versius and hinotori™ have only case reports</a:t>
             </a:r>
           </a:p>
         </p:txBody>
       </p:sp>
       <p:sp>
         <p:nvSpPr>
-          <p:cNvPr id="128" name="Section 3 number"/>
+          <p:cNvPr id="130" name="Section 3 title bar"/>
           <p:cNvSpPr txBox="1"/>
           <p:nvPr/>
         </p:nvSpPr>
         <p:spPr>
           <a:xfrm>
-            <a:off x="685800" y="8293608"/>
-            <a:ext cx="420624" cy="420624"/>
+            <a:off x="685800" y="8385048"/>
+            <a:ext cx="9765792" cy="512064"/>
+          </a:xfrm>
+          <a:prstGeom prst="roundRect">
+            <a:avLst>
+              <a:gd name="adj" fmla="val 18000"/>
+            </a:avLst>
+          </a:prstGeom>
+          <a:solidFill>
+            <a:srgbClr val="213C80"/>
+          </a:solidFill>
+          <a:ln>
+            <a:noFill/>
+          </a:ln>
+        </p:spPr>
+        <p:txBody>
+          <a:bodyPr wrap="square" lIns="0" tIns="0" rIns="0" bIns="0" anchor="t">
+            <a:noAutofit/>
+          </a:bodyPr>
+          <a:lstStyle/>
+          <a:p>
+            <a:pPr marL="0" indent="0">
+              <a:spcBef>
+                <a:spcPts val="0"/>
+              </a:spcBef>
+              <a:spcAft>
+                <a:spcPts val="0"/>
+              </a:spcAft>
+              <a:buNone/>
+            </a:pPr>
+            <a:r>
+              <a:rPr lang="en-US" dirty="0"/>
+              <a:t/>
+            </a:r>
+          </a:p>
+        </p:txBody>
+      </p:sp>
+      <p:sp>
+        <p:nvSpPr>
+          <p:cNvPr id="131" name="Section 3 number"/>
+          <p:cNvSpPr txBox="1"/>
+          <p:nvPr/>
+        </p:nvSpPr>
+        <p:spPr>
+          <a:xfrm>
+            <a:off x="777240" y="8449056"/>
+            <a:ext cx="384048" cy="384048"/>
           </a:xfrm>
           <a:prstGeom prst="ellipse">
             <a:avLst/>
@@ -7229,9 +7364,9 @@
               <a:buNone/>
             </a:pPr>
             <a:r>
-              <a:rPr lang="en-US" sz="1200" b="1" dirty="0">
-                <a:solidFill>
-                  <a:srgbClr val="FFFFFF"/>
+              <a:rPr lang="en-US" sz="1250" b="1" dirty="0">
+                <a:solidFill>
+                  <a:srgbClr val="213C80"/>
                 </a:solidFill>
               </a:rPr>
               <a:t>03</a:t>
@@ -7241,14 +7376,14 @@
       </p:sp>
       <p:sp>
         <p:nvSpPr>
-          <p:cNvPr id="129" name="Section 3 title"/>
+          <p:cNvPr id="132" name="Section 3 title"/>
           <p:cNvSpPr txBox="1"/>
           <p:nvPr/>
         </p:nvSpPr>
         <p:spPr>
           <a:xfrm>
-            <a:off x="1234440" y="8293608"/>
-            <a:ext cx="9217152" cy="420624"/>
+            <a:off x="1289304" y="8385048"/>
+            <a:ext cx="9070848" cy="512064"/>
           </a:xfrm>
           <a:prstGeom prst="rect">
             <a:avLst/>
@@ -7276,24 +7411,24 @@
             <a:r>
               <a:rPr lang="en-US" sz="1800" b="1" dirty="0">
                 <a:solidFill>
-                  <a:srgbClr val="213C80"/>
-                </a:solidFill>
-              </a:rPr>
-              <a:t>Operative technique</a:t>
+                  <a:srgbClr val="FFFFFF"/>
+                </a:solidFill>
+              </a:rPr>
+              <a:t>OPERATIVE TECHNIQUE</a:t>
             </a:r>
           </a:p>
         </p:txBody>
       </p:sp>
       <p:sp>
         <p:nvSpPr>
-          <p:cNvPr id="130" name="Figure frame"/>
+          <p:cNvPr id="133" name="Figure frame"/>
           <p:cNvSpPr txBox="1"/>
           <p:nvPr/>
         </p:nvSpPr>
         <p:spPr>
           <a:xfrm>
-            <a:off x="685800" y="8805672"/>
-            <a:ext cx="1792224" cy="1982604"/>
+            <a:off x="685800" y="8988552"/>
+            <a:ext cx="1627632" cy="1798974"/>
           </a:xfrm>
           <a:prstGeom prst="roundRect">
             <a:avLst>
@@ -7331,7 +7466,7 @@
       </p:sp>
       <p:pic>
         <p:nvPicPr>
-          <p:cNvPr id="131" name="Figure 1" descr="Fig. 1 Port placement for robotic distal pancreatectomy"/>
+          <p:cNvPr id="134" name="Figure 1" descr="Fig. 1 Port placement for robotic distal pancreatectomy"/>
           <p:cNvPicPr>
             <a:picLocks noChangeAspect="1"/>
           </p:cNvPicPr>
@@ -7345,8 +7480,8 @@
         </p:blipFill>
         <p:spPr>
           <a:xfrm>
-            <a:off x="758952" y="8878824"/>
-            <a:ext cx="1645920" cy="1836300"/>
+            <a:off x="758952" y="9061704"/>
+            <a:ext cx="1481328" cy="1652670"/>
           </a:xfrm>
           <a:prstGeom prst="rect">
             <a:avLst/>
@@ -7355,14 +7490,14 @@
       </p:pic>
       <p:sp>
         <p:nvSpPr>
-          <p:cNvPr id="132" name="Fig caption"/>
+          <p:cNvPr id="135" name="Fig caption"/>
           <p:cNvSpPr txBox="1"/>
           <p:nvPr/>
         </p:nvSpPr>
         <p:spPr>
           <a:xfrm>
-            <a:off x="685800" y="10824852"/>
-            <a:ext cx="1792224" cy="274320"/>
+            <a:off x="685800" y="10824102"/>
+            <a:ext cx="1627632" cy="274320"/>
           </a:xfrm>
           <a:prstGeom prst="rect">
             <a:avLst/>
@@ -7388,11 +7523,11 @@
               <a:buNone/>
             </a:pPr>
             <a:r>
-              <a:rPr lang="en-US" sz="1050" b="1" dirty="0"/>
+              <a:rPr lang="en-US" sz="1200" b="1" dirty="0"/>
               <a:t xml:space="preserve">Fig. 1 </a:t>
             </a:r>
             <a:r>
-              <a:rPr lang="en-US" sz="1050" dirty="0">
+              <a:rPr lang="en-US" sz="1200" dirty="0">
                 <a:solidFill>
                   <a:srgbClr val="5B6472"/>
                 </a:solidFill>
@@ -7404,14 +7539,14 @@
       </p:sp>
       <p:sp>
         <p:nvSpPr>
-          <p:cNvPr id="133" name="Step 1"/>
+          <p:cNvPr id="136" name="Step 1"/>
           <p:cNvSpPr txBox="1"/>
           <p:nvPr/>
         </p:nvSpPr>
         <p:spPr>
           <a:xfrm>
-            <a:off x="2788920" y="8823960"/>
-            <a:ext cx="347472" cy="347472"/>
+            <a:off x="2624328" y="9025128"/>
+            <a:ext cx="384048" cy="384048"/>
           </a:xfrm>
           <a:prstGeom prst="ellipse">
             <a:avLst/>
@@ -7439,7 +7574,7 @@
               <a:buNone/>
             </a:pPr>
             <a:r>
-              <a:rPr lang="en-US" sz="1100" b="1" dirty="0">
+              <a:rPr lang="en-US" sz="1300" b="1" dirty="0">
                 <a:solidFill>
                   <a:srgbClr val="FFFFFF"/>
                 </a:solidFill>
@@ -7451,14 +7586,14 @@
       </p:sp>
       <p:sp>
         <p:nvSpPr>
-          <p:cNvPr id="134" name="Step 1 text"/>
+          <p:cNvPr id="137" name="Step 1 text"/>
           <p:cNvSpPr txBox="1"/>
           <p:nvPr/>
         </p:nvSpPr>
         <p:spPr>
           <a:xfrm>
-            <a:off x="3246120" y="8805672"/>
-            <a:ext cx="3236976" cy="713232"/>
+            <a:off x="3081528" y="8988552"/>
+            <a:ext cx="3319272" cy="713232"/>
           </a:xfrm>
           <a:prstGeom prst="rect">
             <a:avLst/>
@@ -7484,7 +7619,7 @@
               <a:buNone/>
             </a:pPr>
             <a:r>
-              <a:rPr lang="en-US" sz="1200" b="1" dirty="0">
+              <a:rPr lang="en-US" sz="1400" b="1" dirty="0">
                 <a:solidFill>
                   <a:srgbClr val="213C80"/>
                 </a:solidFill>
@@ -7503,26 +7638,26 @@
               <a:buNone/>
             </a:pPr>
             <a:r>
-              <a:rPr lang="en-US" sz="1150" dirty="0">
+              <a:rPr lang="en-US" sz="1350" dirty="0">
                 <a:solidFill>
                   <a:srgbClr val="1F2937"/>
                 </a:solidFill>
               </a:rPr>
-              <a:t>Supine or split legs; steep reverse Trendelenburg; dock</a:t>
+              <a:t>Supine; reverse Trendelenburg; dock</a:t>
             </a:r>
           </a:p>
         </p:txBody>
       </p:sp>
       <p:sp>
         <p:nvSpPr>
-          <p:cNvPr id="135" name="Step 2"/>
+          <p:cNvPr id="138" name="Step 2"/>
           <p:cNvSpPr txBox="1"/>
           <p:nvPr/>
         </p:nvSpPr>
         <p:spPr>
           <a:xfrm>
-            <a:off x="2788920" y="9482328"/>
-            <a:ext cx="347472" cy="347472"/>
+            <a:off x="2624328" y="9720072"/>
+            <a:ext cx="384048" cy="384048"/>
           </a:xfrm>
           <a:prstGeom prst="ellipse">
             <a:avLst/>
@@ -7550,7 +7685,7 @@
               <a:buNone/>
             </a:pPr>
             <a:r>
-              <a:rPr lang="en-US" sz="1100" b="1" dirty="0">
+              <a:rPr lang="en-US" sz="1300" b="1" dirty="0">
                 <a:solidFill>
                   <a:srgbClr val="FFFFFF"/>
                 </a:solidFill>
@@ -7562,14 +7697,14 @@
       </p:sp>
       <p:sp>
         <p:nvSpPr>
-          <p:cNvPr id="136" name="Step 2 text"/>
+          <p:cNvPr id="139" name="Step 2 text"/>
           <p:cNvSpPr txBox="1"/>
           <p:nvPr/>
         </p:nvSpPr>
         <p:spPr>
           <a:xfrm>
-            <a:off x="3246120" y="9464040"/>
-            <a:ext cx="3236976" cy="713232"/>
+            <a:off x="3081528" y="9683496"/>
+            <a:ext cx="3319272" cy="713232"/>
           </a:xfrm>
           <a:prstGeom prst="rect">
             <a:avLst/>
@@ -7595,7 +7730,7 @@
               <a:buNone/>
             </a:pPr>
             <a:r>
-              <a:rPr lang="en-US" sz="1200" b="1" dirty="0">
+              <a:rPr lang="en-US" sz="1400" b="1" dirty="0">
                 <a:solidFill>
                   <a:srgbClr val="213C80"/>
                 </a:solidFill>
@@ -7614,7 +7749,7 @@
               <a:buNone/>
             </a:pPr>
             <a:r>
-              <a:rPr lang="en-US" sz="1150" dirty="0">
+              <a:rPr lang="en-US" sz="1350" dirty="0">
                 <a:solidFill>
                   <a:srgbClr val="1F2937"/>
                 </a:solidFill>
@@ -7626,14 +7761,14 @@
       </p:sp>
       <p:sp>
         <p:nvSpPr>
-          <p:cNvPr id="137" name="Step 3"/>
+          <p:cNvPr id="140" name="Step 3"/>
           <p:cNvSpPr txBox="1"/>
           <p:nvPr/>
         </p:nvSpPr>
         <p:spPr>
           <a:xfrm>
-            <a:off x="2788920" y="10140696"/>
-            <a:ext cx="347472" cy="347472"/>
+            <a:off x="2624328" y="10415016"/>
+            <a:ext cx="384048" cy="384048"/>
           </a:xfrm>
           <a:prstGeom prst="ellipse">
             <a:avLst/>
@@ -7661,7 +7796,7 @@
               <a:buNone/>
             </a:pPr>
             <a:r>
-              <a:rPr lang="en-US" sz="1100" b="1" dirty="0">
+              <a:rPr lang="en-US" sz="1300" b="1" dirty="0">
                 <a:solidFill>
                   <a:srgbClr val="FFFFFF"/>
                 </a:solidFill>
@@ -7673,14 +7808,14 @@
       </p:sp>
       <p:sp>
         <p:nvSpPr>
-          <p:cNvPr id="138" name="Step 3 text"/>
+          <p:cNvPr id="141" name="Step 3 text"/>
           <p:cNvSpPr txBox="1"/>
           <p:nvPr/>
         </p:nvSpPr>
         <p:spPr>
           <a:xfrm>
-            <a:off x="3246120" y="10122408"/>
-            <a:ext cx="3236976" cy="713232"/>
+            <a:off x="3081528" y="10378440"/>
+            <a:ext cx="3319272" cy="713232"/>
           </a:xfrm>
           <a:prstGeom prst="rect">
             <a:avLst/>
@@ -7706,7 +7841,7 @@
               <a:buNone/>
             </a:pPr>
             <a:r>
-              <a:rPr lang="en-US" sz="1200" b="1" dirty="0">
+              <a:rPr lang="en-US" sz="1400" b="1" dirty="0">
                 <a:solidFill>
                   <a:srgbClr val="213C80"/>
                 </a:solidFill>
@@ -7725,26 +7860,26 @@
               <a:buNone/>
             </a:pPr>
             <a:r>
-              <a:rPr lang="en-US" sz="1150" dirty="0">
+              <a:rPr lang="en-US" sz="1350" dirty="0">
                 <a:solidFill>
                   <a:srgbClr val="1F2937"/>
                 </a:solidFill>
               </a:rPr>
-              <a:t>Splenic artery and splenic vein</a:t>
+              <a:t>Splenic artery and vein</a:t>
             </a:r>
           </a:p>
         </p:txBody>
       </p:sp>
       <p:sp>
         <p:nvSpPr>
-          <p:cNvPr id="139" name="Step 4"/>
+          <p:cNvPr id="142" name="Step 4"/>
           <p:cNvSpPr txBox="1"/>
           <p:nvPr/>
         </p:nvSpPr>
         <p:spPr>
           <a:xfrm>
-            <a:off x="6757416" y="8823960"/>
-            <a:ext cx="347472" cy="347472"/>
+            <a:off x="6675120" y="9025128"/>
+            <a:ext cx="384048" cy="384048"/>
           </a:xfrm>
           <a:prstGeom prst="ellipse">
             <a:avLst/>
@@ -7772,7 +7907,7 @@
               <a:buNone/>
             </a:pPr>
             <a:r>
-              <a:rPr lang="en-US" sz="1100" b="1" dirty="0">
+              <a:rPr lang="en-US" sz="1300" b="1" dirty="0">
                 <a:solidFill>
                   <a:srgbClr val="FFFFFF"/>
                 </a:solidFill>
@@ -7784,14 +7919,14 @@
       </p:sp>
       <p:sp>
         <p:nvSpPr>
-          <p:cNvPr id="140" name="Step 4 text"/>
+          <p:cNvPr id="143" name="Step 4 text"/>
           <p:cNvSpPr txBox="1"/>
           <p:nvPr/>
         </p:nvSpPr>
         <p:spPr>
           <a:xfrm>
-            <a:off x="7214616" y="8805672"/>
-            <a:ext cx="3236976" cy="713232"/>
+            <a:off x="7132320" y="8988552"/>
+            <a:ext cx="3319272" cy="713232"/>
           </a:xfrm>
           <a:prstGeom prst="rect">
             <a:avLst/>
@@ -7817,7 +7952,7 @@
               <a:buNone/>
             </a:pPr>
             <a:r>
-              <a:rPr lang="en-US" sz="1200" b="1" dirty="0">
+              <a:rPr lang="en-US" sz="1400" b="1" dirty="0">
                 <a:solidFill>
                   <a:srgbClr val="213C80"/>
                 </a:solidFill>
@@ -7836,26 +7971,26 @@
               <a:buNone/>
             </a:pPr>
             <a:r>
-              <a:rPr lang="en-US" sz="1150" dirty="0">
+              <a:rPr lang="en-US" sz="1350" dirty="0">
                 <a:solidFill>
                   <a:srgbClr val="1F2937"/>
                 </a:solidFill>
               </a:rPr>
-              <a:t>Pancreas with a macroscopic margin</a:t>
+              <a:t>Pancreas with clear margin</a:t>
             </a:r>
           </a:p>
         </p:txBody>
       </p:sp>
       <p:sp>
         <p:nvSpPr>
-          <p:cNvPr id="141" name="Step 5"/>
+          <p:cNvPr id="144" name="Step 5"/>
           <p:cNvSpPr txBox="1"/>
           <p:nvPr/>
         </p:nvSpPr>
         <p:spPr>
           <a:xfrm>
-            <a:off x="6757416" y="9482328"/>
-            <a:ext cx="347472" cy="347472"/>
+            <a:off x="6675120" y="9720072"/>
+            <a:ext cx="384048" cy="384048"/>
           </a:xfrm>
           <a:prstGeom prst="ellipse">
             <a:avLst/>
@@ -7883,7 +8018,7 @@
               <a:buNone/>
             </a:pPr>
             <a:r>
-              <a:rPr lang="en-US" sz="1100" b="1" dirty="0">
+              <a:rPr lang="en-US" sz="1300" b="1" dirty="0">
                 <a:solidFill>
                   <a:srgbClr val="FFFFFF"/>
                 </a:solidFill>
@@ -7895,14 +8030,14 @@
       </p:sp>
       <p:sp>
         <p:nvSpPr>
-          <p:cNvPr id="142" name="Step 5 text"/>
+          <p:cNvPr id="145" name="Step 5 text"/>
           <p:cNvSpPr txBox="1"/>
           <p:nvPr/>
         </p:nvSpPr>
         <p:spPr>
           <a:xfrm>
-            <a:off x="7214616" y="9464040"/>
-            <a:ext cx="3236976" cy="713232"/>
+            <a:off x="7132320" y="9683496"/>
+            <a:ext cx="3319272" cy="713232"/>
           </a:xfrm>
           <a:prstGeom prst="rect">
             <a:avLst/>
@@ -7928,7 +8063,7 @@
               <a:buNone/>
             </a:pPr>
             <a:r>
-              <a:rPr lang="en-US" sz="1200" b="1" dirty="0">
+              <a:rPr lang="en-US" sz="1400" b="1" dirty="0">
                 <a:solidFill>
                   <a:srgbClr val="213C80"/>
                 </a:solidFill>
@@ -7947,26 +8082,26 @@
               <a:buNone/>
             </a:pPr>
             <a:r>
-              <a:rPr lang="en-US" sz="1150" dirty="0">
+              <a:rPr lang="en-US" sz="1350" dirty="0">
                 <a:solidFill>
                   <a:srgbClr val="1F2937"/>
                 </a:solidFill>
               </a:rPr>
-              <a:t>En bloc retroperitoneal dissection ± spleen</a:t>
+              <a:t>En bloc ± spleen</a:t>
             </a:r>
           </a:p>
         </p:txBody>
       </p:sp>
       <p:sp>
         <p:nvSpPr>
-          <p:cNvPr id="143" name="Spleen note"/>
+          <p:cNvPr id="146" name="Spleen note"/>
           <p:cNvSpPr txBox="1"/>
           <p:nvPr/>
         </p:nvSpPr>
         <p:spPr>
           <a:xfrm>
-            <a:off x="6757416" y="10122408"/>
-            <a:ext cx="3694176" cy="603504"/>
+            <a:off x="6675120" y="10378440"/>
+            <a:ext cx="3776472" cy="640080"/>
           </a:xfrm>
           <a:prstGeom prst="roundRect">
             <a:avLst>
@@ -7996,7 +8131,7 @@
               <a:buNone/>
             </a:pPr>
             <a:r>
-              <a:rPr lang="en-US" sz="1150" b="1" dirty="0">
+              <a:rPr lang="en-US" sz="1300" b="1" dirty="0">
                 <a:solidFill>
                   <a:srgbClr val="213C80"/>
                 </a:solidFill>
@@ -8004,22 +8139,67 @@
               <a:t xml:space="preserve">Spleen preserving: </a:t>
             </a:r>
             <a:r>
-              <a:rPr lang="en-US" sz="1150" dirty="0"/>
-              <a:t>splenic vessel preservation or Warshaw technique</a:t>
+              <a:rPr lang="en-US" sz="1300" dirty="0"/>
+              <a:t>vessel preservation or Warshaw</a:t>
             </a:r>
           </a:p>
         </p:txBody>
       </p:sp>
       <p:sp>
         <p:nvSpPr>
-          <p:cNvPr id="144" name="Section 4 number"/>
+          <p:cNvPr id="147" name="Section 4 title bar"/>
           <p:cNvSpPr txBox="1"/>
           <p:nvPr/>
         </p:nvSpPr>
         <p:spPr>
           <a:xfrm>
-            <a:off x="685800" y="11373492"/>
-            <a:ext cx="420624" cy="420624"/>
+            <a:off x="685800" y="11299590"/>
+            <a:ext cx="9765792" cy="512064"/>
+          </a:xfrm>
+          <a:prstGeom prst="roundRect">
+            <a:avLst>
+              <a:gd name="adj" fmla="val 18000"/>
+            </a:avLst>
+          </a:prstGeom>
+          <a:solidFill>
+            <a:srgbClr val="213C80"/>
+          </a:solidFill>
+          <a:ln>
+            <a:noFill/>
+          </a:ln>
+        </p:spPr>
+        <p:txBody>
+          <a:bodyPr wrap="square" lIns="0" tIns="0" rIns="0" bIns="0" anchor="t">
+            <a:noAutofit/>
+          </a:bodyPr>
+          <a:lstStyle/>
+          <a:p>
+            <a:pPr marL="0" indent="0">
+              <a:spcBef>
+                <a:spcPts val="0"/>
+              </a:spcBef>
+              <a:spcAft>
+                <a:spcPts val="0"/>
+              </a:spcAft>
+              <a:buNone/>
+            </a:pPr>
+            <a:r>
+              <a:rPr lang="en-US" dirty="0"/>
+              <a:t/>
+            </a:r>
+          </a:p>
+        </p:txBody>
+      </p:sp>
+      <p:sp>
+        <p:nvSpPr>
+          <p:cNvPr id="148" name="Section 4 number"/>
+          <p:cNvSpPr txBox="1"/>
+          <p:nvPr/>
+        </p:nvSpPr>
+        <p:spPr>
+          <a:xfrm>
+            <a:off x="777240" y="11363598"/>
+            <a:ext cx="384048" cy="384048"/>
           </a:xfrm>
           <a:prstGeom prst="ellipse">
             <a:avLst/>
@@ -8047,9 +8227,9 @@
               <a:buNone/>
             </a:pPr>
             <a:r>
-              <a:rPr lang="en-US" sz="1200" b="1" dirty="0">
-                <a:solidFill>
-                  <a:srgbClr val="FFFFFF"/>
+              <a:rPr lang="en-US" sz="1250" b="1" dirty="0">
+                <a:solidFill>
+                  <a:srgbClr val="213C80"/>
                 </a:solidFill>
               </a:rPr>
               <a:t>04</a:t>
@@ -8059,14 +8239,14 @@
       </p:sp>
       <p:sp>
         <p:nvSpPr>
-          <p:cNvPr id="145" name="Section 4 title"/>
+          <p:cNvPr id="149" name="Section 4 title"/>
           <p:cNvSpPr txBox="1"/>
           <p:nvPr/>
         </p:nvSpPr>
         <p:spPr>
           <a:xfrm>
-            <a:off x="1234440" y="11373492"/>
-            <a:ext cx="9217152" cy="420624"/>
+            <a:off x="1289304" y="11299590"/>
+            <a:ext cx="9070848" cy="512064"/>
           </a:xfrm>
           <a:prstGeom prst="rect">
             <a:avLst/>
@@ -8094,36 +8274,36 @@
             <a:r>
               <a:rPr lang="en-US" sz="1800" b="1" dirty="0">
                 <a:solidFill>
-                  <a:srgbClr val="213C80"/>
-                </a:solidFill>
-              </a:rPr>
-              <a:t>Clinical outcomes of RDP</a:t>
+                  <a:srgbClr val="FFFFFF"/>
+                </a:solidFill>
+              </a:rPr>
+              <a:t>CLINICAL OUTCOMES OF RDP</a:t>
             </a:r>
           </a:p>
         </p:txBody>
       </p:sp>
       <p:graphicFrame>
         <p:nvGraphicFramePr>
-          <p:cNvPr id="146" name="Outcomes table"/>
+          <p:cNvPr id="150" name="Outcomes table"/>
           <p:cNvGraphicFramePr>
             <a:graphicFrameLocks noGrp="1"/>
           </p:cNvGraphicFramePr>
           <p:nvPr/>
         </p:nvGraphicFramePr>
         <p:xfrm>
-          <a:off x="685800" y="11885556"/>
-          <a:ext cx="9765792" cy="2651760"/>
+          <a:off x="685800" y="11903094"/>
+          <a:ext cx="9765792" cy="2798064"/>
         </p:xfrm>
         <a:graphic>
           <a:graphicData uri="http://schemas.openxmlformats.org/drawingml/2006/table">
             <a:tbl>
               <a:tblPr firstRow="1" bandRow="1"/>
               <a:tblGrid>
-                <a:gridCol w="2103120"/>
-                <a:gridCol w="3566160"/>
+                <a:gridCol w="2377440"/>
+                <a:gridCol w="3291840"/>
                 <a:gridCol w="4096512"/>
               </a:tblGrid>
-              <a:tr h="347472">
+              <a:tr h="365760">
                 <a:tc>
                   <a:txBody>
                     <a:bodyPr/>
@@ -8139,7 +8319,7 @@
                         <a:buNone/>
                       </a:pPr>
                       <a:r>
-                        <a:rPr lang="en-US" sz="1200" b="1" dirty="0">
+                        <a:rPr lang="en-US" sz="1350" b="1" dirty="0">
                           <a:solidFill>
                             <a:srgbClr val="FFFFFF"/>
                           </a:solidFill>
@@ -8189,7 +8369,7 @@
                         <a:buNone/>
                       </a:pPr>
                       <a:r>
-                        <a:rPr lang="en-US" sz="1200" b="1" dirty="0">
+                        <a:rPr lang="en-US" sz="1350" b="1" dirty="0">
                           <a:solidFill>
                             <a:srgbClr val="FFFFFF"/>
                           </a:solidFill>
@@ -8239,7 +8419,7 @@
                         <a:buNone/>
                       </a:pPr>
                       <a:r>
-                        <a:rPr lang="en-US" sz="1200" b="1" dirty="0">
+                        <a:rPr lang="en-US" sz="1350" b="1" dirty="0">
                           <a:solidFill>
                             <a:srgbClr val="FFFFFF"/>
                           </a:solidFill>
@@ -8275,7 +8455,7 @@
                   </a:tcPr>
                 </a:tc>
               </a:tr>
-              <a:tr h="329184">
+              <a:tr h="347472">
                 <a:tc>
                   <a:txBody>
                     <a:bodyPr/>
@@ -8291,7 +8471,7 @@
                         <a:buNone/>
                       </a:pPr>
                       <a:r>
-                        <a:rPr lang="en-US" sz="1200" b="1" dirty="0">
+                        <a:rPr lang="en-US" sz="1300" b="1" dirty="0">
                           <a:solidFill>
                             <a:srgbClr val="213C80"/>
                           </a:solidFill>
@@ -8341,7 +8521,7 @@
                         <a:buNone/>
                       </a:pPr>
                       <a:r>
-                        <a:rPr lang="en-US" sz="1200" b="1" dirty="0">
+                        <a:rPr lang="en-US" sz="1300" b="1" dirty="0">
                           <a:solidFill>
                             <a:srgbClr val="2E7D4F"/>
                           </a:solidFill>
@@ -8349,7 +8529,7 @@
                         <a:t xml:space="preserve">▼ </a:t>
                       </a:r>
                       <a:r>
-                        <a:rPr lang="en-US" sz="1200" b="1" dirty="0">
+                        <a:rPr lang="en-US" sz="1300" b="1" dirty="0">
                           <a:solidFill>
                             <a:srgbClr val="2E7D4F"/>
                           </a:solidFill>
@@ -8399,7 +8579,7 @@
                         <a:buNone/>
                       </a:pPr>
                       <a:r>
-                        <a:rPr lang="en-US" sz="1200" b="1" dirty="0">
+                        <a:rPr lang="en-US" sz="1300" b="1" dirty="0">
                           <a:solidFill>
                             <a:srgbClr val="2E7D4F"/>
                           </a:solidFill>
@@ -8407,12 +8587,12 @@
                         <a:t xml:space="preserve">▼ </a:t>
                       </a:r>
                       <a:r>
-                        <a:rPr lang="en-US" sz="1200" b="1" dirty="0">
+                        <a:rPr lang="en-US" sz="1300" b="1" dirty="0">
                           <a:solidFill>
                             <a:srgbClr val="2E7D4F"/>
                           </a:solidFill>
                         </a:rPr>
-                        <a:t>Lower (planned spleen preservation)</a:t>
+                        <a:t>Lower (planned SP)</a:t>
                       </a:r>
                     </a:p>
                   </a:txBody>
@@ -8443,7 +8623,7 @@
                   </a:tcPr>
                 </a:tc>
               </a:tr>
-              <a:tr h="329184">
+              <a:tr h="347472">
                 <a:tc>
                   <a:txBody>
                     <a:bodyPr/>
@@ -8459,7 +8639,7 @@
                         <a:buNone/>
                       </a:pPr>
                       <a:r>
-                        <a:rPr lang="en-US" sz="1200" b="1" dirty="0">
+                        <a:rPr lang="en-US" sz="1300" b="1" dirty="0">
                           <a:solidFill>
                             <a:srgbClr val="213C80"/>
                           </a:solidFill>
@@ -8509,7 +8689,7 @@
                         <a:buNone/>
                       </a:pPr>
                       <a:r>
-                        <a:rPr lang="en-US" sz="1200" b="1" dirty="0">
+                        <a:rPr lang="en-US" sz="1300" b="1" dirty="0">
                           <a:solidFill>
                             <a:srgbClr val="2E7D4F"/>
                           </a:solidFill>
@@ -8517,12 +8697,12 @@
                         <a:t xml:space="preserve">▼ </a:t>
                       </a:r>
                       <a:r>
-                        <a:rPr lang="en-US" sz="1200" b="1" dirty="0">
+                        <a:rPr lang="en-US" sz="1300" b="1" dirty="0">
                           <a:solidFill>
                             <a:srgbClr val="2E7D4F"/>
                           </a:solidFill>
                         </a:rPr>
-                        <a:t>Fewer (fistula, respiratory, wound)</a:t>
+                        <a:t>Fewer (fistula, wound)</a:t>
                       </a:r>
                     </a:p>
                   </a:txBody>
@@ -8567,7 +8747,7 @@
                         <a:buNone/>
                       </a:pPr>
                       <a:r>
-                        <a:rPr lang="en-US" sz="1200" b="1" dirty="0">
+                        <a:rPr lang="en-US" sz="1300" b="1" dirty="0">
                           <a:solidFill>
                             <a:srgbClr val="5B6472"/>
                           </a:solidFill>
@@ -8575,12 +8755,12 @@
                         <a:t xml:space="preserve">= </a:t>
                       </a:r>
                       <a:r>
-                        <a:rPr lang="en-US" sz="1200" dirty="0">
+                        <a:rPr lang="en-US" sz="1300" dirty="0">
                           <a:solidFill>
                             <a:srgbClr val="5B6472"/>
                           </a:solidFill>
                         </a:rPr>
-                        <a:t>Similar overall, major and fistula</a:t>
+                        <a:t>Similar overall and fistula</a:t>
                       </a:r>
                     </a:p>
                   </a:txBody>
@@ -8611,7 +8791,7 @@
                   </a:tcPr>
                 </a:tc>
               </a:tr>
-              <a:tr h="329184">
+              <a:tr h="347472">
                 <a:tc>
                   <a:txBody>
                     <a:bodyPr/>
@@ -8627,7 +8807,7 @@
                         <a:buNone/>
                       </a:pPr>
                       <a:r>
-                        <a:rPr lang="en-US" sz="1200" b="1" dirty="0">
+                        <a:rPr lang="en-US" sz="1300" b="1" dirty="0">
                           <a:solidFill>
                             <a:srgbClr val="213C80"/>
                           </a:solidFill>
@@ -8677,7 +8857,7 @@
                         <a:buNone/>
                       </a:pPr>
                       <a:r>
-                        <a:rPr lang="en-US" sz="1200" b="1" dirty="0">
+                        <a:rPr lang="en-US" sz="1300" b="1" dirty="0">
                           <a:solidFill>
                             <a:srgbClr val="2E7D4F"/>
                           </a:solidFill>
@@ -8685,7 +8865,7 @@
                         <a:t xml:space="preserve">▼ </a:t>
                       </a:r>
                       <a:r>
-                        <a:rPr lang="en-US" sz="1200" b="1" dirty="0">
+                        <a:rPr lang="en-US" sz="1300" b="1" dirty="0">
                           <a:solidFill>
                             <a:srgbClr val="2E7D4F"/>
                           </a:solidFill>
@@ -8735,7 +8915,7 @@
                         <a:buNone/>
                       </a:pPr>
                       <a:r>
-                        <a:rPr lang="en-US" sz="1200" b="1" dirty="0">
+                        <a:rPr lang="en-US" sz="1300" b="1" dirty="0">
                           <a:solidFill>
                             <a:srgbClr val="2E7D4F"/>
                           </a:solidFill>
@@ -8743,7 +8923,7 @@
                         <a:t xml:space="preserve">▼ </a:t>
                       </a:r>
                       <a:r>
-                        <a:rPr lang="en-US" sz="1200" b="1" dirty="0">
+                        <a:rPr lang="en-US" sz="1300" b="1" dirty="0">
                           <a:solidFill>
                             <a:srgbClr val="2E7D4F"/>
                           </a:solidFill>
@@ -8779,7 +8959,7 @@
                   </a:tcPr>
                 </a:tc>
               </a:tr>
-              <a:tr h="329184">
+              <a:tr h="347472">
                 <a:tc>
                   <a:txBody>
                     <a:bodyPr/>
@@ -8795,7 +8975,7 @@
                         <a:buNone/>
                       </a:pPr>
                       <a:r>
-                        <a:rPr lang="en-US" sz="1200" b="1" dirty="0">
+                        <a:rPr lang="en-US" sz="1300" b="1" dirty="0">
                           <a:solidFill>
                             <a:srgbClr val="213C80"/>
                           </a:solidFill>
@@ -8845,7 +9025,7 @@
                         <a:buNone/>
                       </a:pPr>
                       <a:r>
-                        <a:rPr lang="en-US" sz="1200" b="1" dirty="0">
+                        <a:rPr lang="en-US" sz="1300" b="1" dirty="0">
                           <a:solidFill>
                             <a:srgbClr val="5B6472"/>
                           </a:solidFill>
@@ -8853,7 +9033,7 @@
                         <a:t/>
                       </a:r>
                       <a:r>
-                        <a:rPr lang="en-US" sz="1200" dirty="0">
+                        <a:rPr lang="en-US" sz="1300" dirty="0">
                           <a:solidFill>
                             <a:srgbClr val="5B6472"/>
                           </a:solidFill>
@@ -8903,7 +9083,7 @@
                         <a:buNone/>
                       </a:pPr>
                       <a:r>
-                        <a:rPr lang="en-US" sz="1200" b="1" dirty="0">
+                        <a:rPr lang="en-US" sz="1300" b="1" dirty="0">
                           <a:solidFill>
                             <a:srgbClr val="2E7D4F"/>
                           </a:solidFill>
@@ -8911,7 +9091,7 @@
                         <a:t xml:space="preserve">▼ </a:t>
                       </a:r>
                       <a:r>
-                        <a:rPr lang="en-US" sz="1200" b="1" dirty="0">
+                        <a:rPr lang="en-US" sz="1300" b="1" dirty="0">
                           <a:solidFill>
                             <a:srgbClr val="2E7D4F"/>
                           </a:solidFill>
@@ -8947,7 +9127,7 @@
                   </a:tcPr>
                 </a:tc>
               </a:tr>
-              <a:tr h="329184">
+              <a:tr h="347472">
                 <a:tc>
                   <a:txBody>
                     <a:bodyPr/>
@@ -8963,7 +9143,7 @@
                         <a:buNone/>
                       </a:pPr>
                       <a:r>
-                        <a:rPr lang="en-US" sz="1200" b="1" dirty="0">
+                        <a:rPr lang="en-US" sz="1300" b="1" dirty="0">
                           <a:solidFill>
                             <a:srgbClr val="213C80"/>
                           </a:solidFill>
@@ -9013,7 +9193,7 @@
                         <a:buNone/>
                       </a:pPr>
                       <a:r>
-                        <a:rPr lang="en-US" sz="1200" b="1" dirty="0">
+                        <a:rPr lang="en-US" sz="1300" b="1" dirty="0">
                           <a:solidFill>
                             <a:srgbClr val="2E7D4F"/>
                           </a:solidFill>
@@ -9021,7 +9201,7 @@
                         <a:t xml:space="preserve">▲ </a:t>
                       </a:r>
                       <a:r>
-                        <a:rPr lang="en-US" sz="1200" b="1" dirty="0">
+                        <a:rPr lang="en-US" sz="1300" b="1" dirty="0">
                           <a:solidFill>
                             <a:srgbClr val="2E7D4F"/>
                           </a:solidFill>
@@ -9071,7 +9251,7 @@
                         <a:buNone/>
                       </a:pPr>
                       <a:r>
-                        <a:rPr lang="en-US" sz="1200" b="1" dirty="0">
+                        <a:rPr lang="en-US" sz="1300" b="1" dirty="0">
                           <a:solidFill>
                             <a:srgbClr val="2E7D4F"/>
                           </a:solidFill>
@@ -9079,12 +9259,12 @@
                         <a:t xml:space="preserve">▲ </a:t>
                       </a:r>
                       <a:r>
-                        <a:rPr lang="en-US" sz="1200" b="1" dirty="0">
+                        <a:rPr lang="en-US" sz="1300" b="1" dirty="0">
                           <a:solidFill>
                             <a:srgbClr val="2E7D4F"/>
                           </a:solidFill>
                         </a:rPr>
-                        <a:t>Higher; fewer conversions to splenectomy</a:t>
+                        <a:t>Higher; fewer splenectomies</a:t>
                       </a:r>
                     </a:p>
                   </a:txBody>
@@ -9115,7 +9295,7 @@
                   </a:tcPr>
                 </a:tc>
               </a:tr>
-              <a:tr h="329184">
+              <a:tr h="347472">
                 <a:tc>
                   <a:txBody>
                     <a:bodyPr/>
@@ -9131,7 +9311,7 @@
                         <a:buNone/>
                       </a:pPr>
                       <a:r>
-                        <a:rPr lang="en-US" sz="1200" b="1" dirty="0">
+                        <a:rPr lang="en-US" sz="1300" b="1" dirty="0">
                           <a:solidFill>
                             <a:srgbClr val="213C80"/>
                           </a:solidFill>
@@ -9181,7 +9361,7 @@
                         <a:buNone/>
                       </a:pPr>
                       <a:r>
-                        <a:rPr lang="en-US" sz="1200" b="1" dirty="0">
+                        <a:rPr lang="en-US" sz="1300" b="1" dirty="0">
                           <a:solidFill>
                             <a:srgbClr val="5B6472"/>
                           </a:solidFill>
@@ -9189,12 +9369,12 @@
                         <a:t xml:space="preserve">= </a:t>
                       </a:r>
                       <a:r>
-                        <a:rPr lang="en-US" sz="1200" dirty="0">
+                        <a:rPr lang="en-US" sz="1300" dirty="0">
                           <a:solidFill>
                             <a:srgbClr val="5B6472"/>
                           </a:solidFill>
                         </a:rPr>
-                        <a:t>Non-inferior R0 and lymph node yield</a:t>
+                        <a:t>Non-inferior R0 and nodes</a:t>
                       </a:r>
                     </a:p>
                   </a:txBody>
@@ -9239,7 +9419,7 @@
                         <a:buNone/>
                       </a:pPr>
                       <a:r>
-                        <a:rPr lang="en-US" sz="1200" b="1" dirty="0">
+                        <a:rPr lang="en-US" sz="1300" b="1" dirty="0">
                           <a:solidFill>
                             <a:srgbClr val="2E7D4F"/>
                           </a:solidFill>
@@ -9247,7 +9427,7 @@
                         <a:t xml:space="preserve">▲ </a:t>
                       </a:r>
                       <a:r>
-                        <a:rPr lang="en-US" sz="1200" b="1" dirty="0">
+                        <a:rPr lang="en-US" sz="1300" b="1" dirty="0">
                           <a:solidFill>
                             <a:srgbClr val="2E7D4F"/>
                           </a:solidFill>
@@ -9283,7 +9463,7 @@
                   </a:tcPr>
                 </a:tc>
               </a:tr>
-              <a:tr h="329184">
+              <a:tr h="347472">
                 <a:tc>
                   <a:txBody>
                     <a:bodyPr/>
@@ -9299,7 +9479,7 @@
                         <a:buNone/>
                       </a:pPr>
                       <a:r>
-                        <a:rPr lang="en-US" sz="1200" b="1" dirty="0">
+                        <a:rPr lang="en-US" sz="1300" b="1" dirty="0">
                           <a:solidFill>
                             <a:srgbClr val="213C80"/>
                           </a:solidFill>
@@ -9349,7 +9529,7 @@
                         <a:buNone/>
                       </a:pPr>
                       <a:r>
-                        <a:rPr lang="en-US" sz="1200" b="1" dirty="0">
+                        <a:rPr lang="en-US" sz="1300" b="1" dirty="0">
                           <a:solidFill>
                             <a:srgbClr val="5B6472"/>
                           </a:solidFill>
@@ -9357,7 +9537,7 @@
                         <a:t xml:space="preserve">= </a:t>
                       </a:r>
                       <a:r>
-                        <a:rPr lang="en-US" sz="1200" dirty="0">
+                        <a:rPr lang="en-US" sz="1300" dirty="0">
                           <a:solidFill>
                             <a:srgbClr val="5B6472"/>
                           </a:solidFill>
@@ -9407,7 +9587,7 @@
                         <a:buNone/>
                       </a:pPr>
                       <a:r>
-                        <a:rPr lang="en-US" sz="1200" b="1" dirty="0">
+                        <a:rPr lang="en-US" sz="1300" b="1" dirty="0">
                           <a:solidFill>
                             <a:srgbClr val="B86410"/>
                           </a:solidFill>
@@ -9415,7 +9595,7 @@
                         <a:t xml:space="preserve">▲ </a:t>
                       </a:r>
                       <a:r>
-                        <a:rPr lang="en-US" sz="1200" b="1" dirty="0">
+                        <a:rPr lang="en-US" sz="1300" b="1" dirty="0">
                           <a:solidFill>
                             <a:srgbClr val="B86410"/>
                           </a:solidFill>
@@ -9457,13 +9637,13 @@
       </p:graphicFrame>
       <p:sp>
         <p:nvSpPr>
-          <p:cNvPr id="147" name="Table key"/>
+          <p:cNvPr id="151" name="Table key"/>
           <p:cNvSpPr txBox="1"/>
           <p:nvPr/>
         </p:nvSpPr>
         <p:spPr>
           <a:xfrm>
-            <a:off x="685800" y="14628756"/>
+            <a:off x="685800" y="14792598"/>
             <a:ext cx="9765792" cy="274320"/>
           </a:xfrm>
           <a:prstGeom prst="rect">
@@ -9535,21 +9715,66 @@
                   <a:srgbClr val="5B6472"/>
                 </a:solidFill>
               </a:rPr>
-              <a:t>favours comparator</a:t>
+              <a:t>favours comparator     SP, spleen preservation</a:t>
             </a:r>
           </a:p>
         </p:txBody>
       </p:sp>
       <p:sp>
         <p:nvSpPr>
-          <p:cNvPr id="148" name="Section 5 number"/>
+          <p:cNvPr id="152" name="Section 5 title bar"/>
           <p:cNvSpPr txBox="1"/>
           <p:nvPr/>
         </p:nvSpPr>
         <p:spPr>
           <a:xfrm>
-            <a:off x="685800" y="15159108"/>
-            <a:ext cx="420624" cy="420624"/>
+            <a:off x="685800" y="15231510"/>
+            <a:ext cx="4677156" cy="512064"/>
+          </a:xfrm>
+          <a:prstGeom prst="roundRect">
+            <a:avLst>
+              <a:gd name="adj" fmla="val 18000"/>
+            </a:avLst>
+          </a:prstGeom>
+          <a:solidFill>
+            <a:srgbClr val="213C80"/>
+          </a:solidFill>
+          <a:ln>
+            <a:noFill/>
+          </a:ln>
+        </p:spPr>
+        <p:txBody>
+          <a:bodyPr wrap="square" lIns="0" tIns="0" rIns="0" bIns="0" anchor="t">
+            <a:noAutofit/>
+          </a:bodyPr>
+          <a:lstStyle/>
+          <a:p>
+            <a:pPr marL="0" indent="0">
+              <a:spcBef>
+                <a:spcPts val="0"/>
+              </a:spcBef>
+              <a:spcAft>
+                <a:spcPts val="0"/>
+              </a:spcAft>
+              <a:buNone/>
+            </a:pPr>
+            <a:r>
+              <a:rPr lang="en-US" dirty="0"/>
+              <a:t/>
+            </a:r>
+          </a:p>
+        </p:txBody>
+      </p:sp>
+      <p:sp>
+        <p:nvSpPr>
+          <p:cNvPr id="153" name="Section 5 number"/>
+          <p:cNvSpPr txBox="1"/>
+          <p:nvPr/>
+        </p:nvSpPr>
+        <p:spPr>
+          <a:xfrm>
+            <a:off x="777240" y="15295518"/>
+            <a:ext cx="384048" cy="384048"/>
           </a:xfrm>
           <a:prstGeom prst="ellipse">
             <a:avLst/>
@@ -9577,9 +9802,9 @@
               <a:buNone/>
             </a:pPr>
             <a:r>
-              <a:rPr lang="en-US" sz="1200" b="1" dirty="0">
-                <a:solidFill>
-                  <a:srgbClr val="FFFFFF"/>
+              <a:rPr lang="en-US" sz="1250" b="1" dirty="0">
+                <a:solidFill>
+                  <a:srgbClr val="213C80"/>
                 </a:solidFill>
               </a:rPr>
               <a:t>05</a:t>
@@ -9589,14 +9814,14 @@
       </p:sp>
       <p:sp>
         <p:nvSpPr>
-          <p:cNvPr id="149" name="Section 5 title"/>
+          <p:cNvPr id="154" name="Section 5 title"/>
           <p:cNvSpPr txBox="1"/>
           <p:nvPr/>
         </p:nvSpPr>
         <p:spPr>
           <a:xfrm>
-            <a:off x="1234440" y="15159108"/>
-            <a:ext cx="4128516" cy="420624"/>
+            <a:off x="1289304" y="15231510"/>
+            <a:ext cx="3982212" cy="512064"/>
           </a:xfrm>
           <a:prstGeom prst="rect">
             <a:avLst/>
@@ -9624,24 +9849,24 @@
             <a:r>
               <a:rPr lang="en-US" sz="1800" b="1" dirty="0">
                 <a:solidFill>
-                  <a:srgbClr val="213C80"/>
-                </a:solidFill>
-              </a:rPr>
-              <a:t>Cost-effectiveness</a:t>
+                  <a:srgbClr val="FFFFFF"/>
+                </a:solidFill>
+              </a:rPr>
+              <a:t>COST-EFFECTIVENESS</a:t>
             </a:r>
           </a:p>
         </p:txBody>
       </p:sp>
       <p:sp>
         <p:nvSpPr>
-          <p:cNvPr id="150" name="Cost chip Operative cost"/>
+          <p:cNvPr id="155" name="Cost chip Operative cost"/>
           <p:cNvSpPr txBox="1"/>
           <p:nvPr/>
         </p:nvSpPr>
         <p:spPr>
           <a:xfrm>
-            <a:off x="685800" y="15671172"/>
-            <a:ext cx="1498092" cy="777240"/>
+            <a:off x="685800" y="15835014"/>
+            <a:ext cx="1498092" cy="841248"/>
           </a:xfrm>
           <a:prstGeom prst="roundRect">
             <a:avLst>
@@ -9671,7 +9896,7 @@
               <a:buNone/>
             </a:pPr>
             <a:r>
-              <a:rPr lang="en-US" sz="1050" dirty="0">
+              <a:rPr lang="en-US" sz="1200" dirty="0">
                 <a:solidFill>
                   <a:srgbClr val="5B6472"/>
                 </a:solidFill>
@@ -9690,7 +9915,7 @@
               <a:buNone/>
             </a:pPr>
             <a:r>
-              <a:rPr lang="en-US" sz="1150" b="1" dirty="0">
+              <a:rPr lang="en-US" sz="1300" b="1" dirty="0">
                 <a:solidFill>
                   <a:srgbClr val="B86410"/>
                 </a:solidFill>
@@ -9702,14 +9927,14 @@
       </p:sp>
       <p:sp>
         <p:nvSpPr>
-          <p:cNvPr id="151" name="Cost chip Overall cost"/>
+          <p:cNvPr id="156" name="Cost chip Overall cost"/>
           <p:cNvSpPr txBox="1"/>
           <p:nvPr/>
         </p:nvSpPr>
         <p:spPr>
           <a:xfrm>
-            <a:off x="2275332" y="15671172"/>
-            <a:ext cx="1498092" cy="777240"/>
+            <a:off x="2275332" y="15835014"/>
+            <a:ext cx="1498092" cy="841248"/>
           </a:xfrm>
           <a:prstGeom prst="roundRect">
             <a:avLst>
@@ -9739,7 +9964,7 @@
               <a:buNone/>
             </a:pPr>
             <a:r>
-              <a:rPr lang="en-US" sz="1050" dirty="0">
+              <a:rPr lang="en-US" sz="1200" dirty="0">
                 <a:solidFill>
                   <a:srgbClr val="5B6472"/>
                 </a:solidFill>
@@ -9758,7 +9983,7 @@
               <a:buNone/>
             </a:pPr>
             <a:r>
-              <a:rPr lang="en-US" sz="1150" b="1" dirty="0">
+              <a:rPr lang="en-US" sz="1200" b="1" dirty="0">
                 <a:solidFill>
                   <a:srgbClr val="2E7D4F"/>
                 </a:solidFill>
@@ -9770,14 +9995,14 @@
       </p:sp>
       <p:sp>
         <p:nvSpPr>
-          <p:cNvPr id="152" name="Cost chip Quality of life"/>
+          <p:cNvPr id="157" name="Cost chip Quality of life"/>
           <p:cNvSpPr txBox="1"/>
           <p:nvPr/>
         </p:nvSpPr>
         <p:spPr>
           <a:xfrm>
-            <a:off x="3864864" y="15671172"/>
-            <a:ext cx="1498092" cy="777240"/>
+            <a:off x="3864864" y="15835014"/>
+            <a:ext cx="1498092" cy="841248"/>
           </a:xfrm>
           <a:prstGeom prst="roundRect">
             <a:avLst>
@@ -9807,7 +10032,7 @@
               <a:buNone/>
             </a:pPr>
             <a:r>
-              <a:rPr lang="en-US" sz="1050" dirty="0">
+              <a:rPr lang="en-US" sz="1200" dirty="0">
                 <a:solidFill>
                   <a:srgbClr val="5B6472"/>
                 </a:solidFill>
@@ -9826,7 +10051,7 @@
               <a:buNone/>
             </a:pPr>
             <a:r>
-              <a:rPr lang="en-US" sz="1150" b="1" dirty="0">
+              <a:rPr lang="en-US" sz="1300" b="1" dirty="0">
                 <a:solidFill>
                   <a:srgbClr val="2E7D4F"/>
                 </a:solidFill>
@@ -9838,14 +10063,14 @@
       </p:sp>
       <p:sp>
         <p:nvSpPr>
-          <p:cNvPr id="153" name="Cost bullets"/>
+          <p:cNvPr id="158" name="Cost bullets"/>
           <p:cNvSpPr txBox="1"/>
           <p:nvPr/>
         </p:nvSpPr>
         <p:spPr>
           <a:xfrm>
-            <a:off x="685800" y="16558140"/>
-            <a:ext cx="4677156" cy="960120"/>
+            <a:off x="685800" y="16785990"/>
+            <a:ext cx="4677156" cy="777240"/>
           </a:xfrm>
           <a:prstGeom prst="rect">
             <a:avLst/>
@@ -9875,8 +10100,8 @@
               <a:buChar char="•"/>
             </a:pPr>
             <a:r>
-              <a:rPr lang="en-US" sz="1200" dirty="0"/>
-              <a:t>Theatre costs offset by shorter stay, fewer conversions and lower morbidity; costs fall with volume.</a:t>
+              <a:rPr lang="en-US" sz="1400" dirty="0"/>
+              <a:t>Theatre cost offset by shorter stay</a:t>
             </a:r>
           </a:p>
           <a:p>
@@ -9894,22 +10119,67 @@
               <a:buChar char="•"/>
             </a:pPr>
             <a:r>
-              <a:rPr lang="en-US" sz="1200" dirty="0"/>
-              <a:t>More QALYs than LDP at similar cost (ROBOCOSTES).</a:t>
+              <a:rPr lang="en-US" sz="1400" dirty="0"/>
+              <a:t>More QALYs than LDP at similar cost</a:t>
             </a:r>
           </a:p>
         </p:txBody>
       </p:sp>
       <p:sp>
         <p:nvSpPr>
-          <p:cNvPr id="154" name="Section 6 number"/>
+          <p:cNvPr id="159" name="Section 6 title bar"/>
           <p:cNvSpPr txBox="1"/>
           <p:nvPr/>
         </p:nvSpPr>
         <p:spPr>
           <a:xfrm>
-            <a:off x="5774436" y="15159108"/>
-            <a:ext cx="420624" cy="420624"/>
+            <a:off x="5774436" y="15231510"/>
+            <a:ext cx="4677156" cy="512064"/>
+          </a:xfrm>
+          <a:prstGeom prst="roundRect">
+            <a:avLst>
+              <a:gd name="adj" fmla="val 18000"/>
+            </a:avLst>
+          </a:prstGeom>
+          <a:solidFill>
+            <a:srgbClr val="213C80"/>
+          </a:solidFill>
+          <a:ln>
+            <a:noFill/>
+          </a:ln>
+        </p:spPr>
+        <p:txBody>
+          <a:bodyPr wrap="square" lIns="0" tIns="0" rIns="0" bIns="0" anchor="t">
+            <a:noAutofit/>
+          </a:bodyPr>
+          <a:lstStyle/>
+          <a:p>
+            <a:pPr marL="0" indent="0">
+              <a:spcBef>
+                <a:spcPts val="0"/>
+              </a:spcBef>
+              <a:spcAft>
+                <a:spcPts val="0"/>
+              </a:spcAft>
+              <a:buNone/>
+            </a:pPr>
+            <a:r>
+              <a:rPr lang="en-US" dirty="0"/>
+              <a:t/>
+            </a:r>
+          </a:p>
+        </p:txBody>
+      </p:sp>
+      <p:sp>
+        <p:nvSpPr>
+          <p:cNvPr id="160" name="Section 6 number"/>
+          <p:cNvSpPr txBox="1"/>
+          <p:nvPr/>
+        </p:nvSpPr>
+        <p:spPr>
+          <a:xfrm>
+            <a:off x="5865876" y="15295518"/>
+            <a:ext cx="384048" cy="384048"/>
           </a:xfrm>
           <a:prstGeom prst="ellipse">
             <a:avLst/>
@@ -9937,9 +10207,9 @@
               <a:buNone/>
             </a:pPr>
             <a:r>
-              <a:rPr lang="en-US" sz="1200" b="1" dirty="0">
-                <a:solidFill>
-                  <a:srgbClr val="FFFFFF"/>
+              <a:rPr lang="en-US" sz="1250" b="1" dirty="0">
+                <a:solidFill>
+                  <a:srgbClr val="213C80"/>
                 </a:solidFill>
               </a:rPr>
               <a:t>06</a:t>
@@ -9949,14 +10219,14 @@
       </p:sp>
       <p:sp>
         <p:nvSpPr>
-          <p:cNvPr id="155" name="Section 6 title"/>
+          <p:cNvPr id="161" name="Section 6 title"/>
           <p:cNvSpPr txBox="1"/>
           <p:nvPr/>
         </p:nvSpPr>
         <p:spPr>
           <a:xfrm>
-            <a:off x="6323076" y="15159108"/>
-            <a:ext cx="4128516" cy="420624"/>
+            <a:off x="6377940" y="15231510"/>
+            <a:ext cx="3982212" cy="512064"/>
           </a:xfrm>
           <a:prstGeom prst="rect">
             <a:avLst/>
@@ -9984,23 +10254,23 @@
             <a:r>
               <a:rPr lang="en-US" sz="1800" b="1" dirty="0">
                 <a:solidFill>
-                  <a:srgbClr val="213C80"/>
-                </a:solidFill>
-              </a:rPr>
-              <a:t>Challenges</a:t>
+                  <a:srgbClr val="FFFFFF"/>
+                </a:solidFill>
+              </a:rPr>
+              <a:t>CHALLENGES</a:t>
             </a:r>
           </a:p>
         </p:txBody>
       </p:sp>
       <p:sp>
         <p:nvSpPr>
-          <p:cNvPr id="156" name="Challenge circle Operative time"/>
+          <p:cNvPr id="162" name="Challenge circle Operative time"/>
           <p:cNvSpPr txBox="1"/>
           <p:nvPr/>
         </p:nvSpPr>
         <p:spPr>
           <a:xfrm>
-            <a:off x="5774436" y="15707748"/>
+            <a:off x="5774436" y="15871590"/>
             <a:ext cx="512064" cy="512064"/>
           </a:xfrm>
           <a:prstGeom prst="ellipse">
@@ -10037,7 +10307,7 @@
       </p:sp>
       <p:pic>
         <p:nvPicPr>
-          <p:cNvPr id="157" name="Icon Operative time" descr="Operative time"/>
+          <p:cNvPr id="163" name="Icon Operative time" descr="Operative time"/>
           <p:cNvPicPr>
             <a:picLocks noChangeAspect="1"/>
           </p:cNvPicPr>
@@ -10051,7 +10321,7 @@
         </p:blipFill>
         <p:spPr>
           <a:xfrm>
-            <a:off x="5902452" y="15835764"/>
+            <a:off x="5902452" y="15999606"/>
             <a:ext cx="256032" cy="256032"/>
           </a:xfrm>
           <a:prstGeom prst="rect">
@@ -10061,13 +10331,13 @@
       </p:pic>
       <p:sp>
         <p:nvSpPr>
-          <p:cNvPr id="158" name="Challenge Operative time"/>
+          <p:cNvPr id="164" name="Challenge Operative time"/>
           <p:cNvSpPr txBox="1"/>
           <p:nvPr/>
         </p:nvSpPr>
         <p:spPr>
           <a:xfrm>
-            <a:off x="6432804" y="15671172"/>
+            <a:off x="6432804" y="15835014"/>
             <a:ext cx="4018788" cy="640080"/>
           </a:xfrm>
           <a:prstGeom prst="rect">
@@ -10094,7 +10364,7 @@
               <a:buNone/>
             </a:pPr>
             <a:r>
-              <a:rPr lang="en-US" sz="1200" b="1" dirty="0">
+              <a:rPr lang="en-US" sz="1400" b="1" dirty="0">
                 <a:solidFill>
                   <a:srgbClr val="213C80"/>
                 </a:solidFill>
@@ -10113,25 +10383,25 @@
               <a:buNone/>
             </a:pPr>
             <a:r>
-              <a:rPr lang="en-US" sz="1150" dirty="0">
+              <a:rPr lang="en-US" sz="1350" dirty="0">
                 <a:solidFill>
                   <a:srgbClr val="1F2937"/>
                 </a:solidFill>
               </a:rPr>
-              <a:t>Docking adds time; falls with the learning curve</a:t>
+              <a:t>Docking adds time</a:t>
             </a:r>
           </a:p>
         </p:txBody>
       </p:sp>
       <p:sp>
         <p:nvSpPr>
-          <p:cNvPr id="159" name="Challenge circle Team &amp; training"/>
+          <p:cNvPr id="165" name="Challenge circle Team &amp; training"/>
           <p:cNvSpPr txBox="1"/>
           <p:nvPr/>
         </p:nvSpPr>
         <p:spPr>
           <a:xfrm>
-            <a:off x="5774436" y="16347828"/>
+            <a:off x="5774436" y="16493382"/>
             <a:ext cx="512064" cy="512064"/>
           </a:xfrm>
           <a:prstGeom prst="ellipse">
@@ -10168,7 +10438,7 @@
       </p:sp>
       <p:pic>
         <p:nvPicPr>
-          <p:cNvPr id="160" name="Icon Team &amp; training" descr="Team &amp; training"/>
+          <p:cNvPr id="166" name="Icon Team &amp; training" descr="Team &amp; training"/>
           <p:cNvPicPr>
             <a:picLocks noChangeAspect="1"/>
           </p:cNvPicPr>
@@ -10182,7 +10452,7 @@
         </p:blipFill>
         <p:spPr>
           <a:xfrm>
-            <a:off x="5902452" y="16475844"/>
+            <a:off x="5902452" y="16621398"/>
             <a:ext cx="256032" cy="256032"/>
           </a:xfrm>
           <a:prstGeom prst="rect">
@@ -10192,13 +10462,13 @@
       </p:pic>
       <p:sp>
         <p:nvSpPr>
-          <p:cNvPr id="161" name="Challenge Team &amp; training"/>
+          <p:cNvPr id="167" name="Challenge Team &amp; training"/>
           <p:cNvSpPr txBox="1"/>
           <p:nvPr/>
         </p:nvSpPr>
         <p:spPr>
           <a:xfrm>
-            <a:off x="6432804" y="16311252"/>
+            <a:off x="6432804" y="16456806"/>
             <a:ext cx="4018788" cy="640080"/>
           </a:xfrm>
           <a:prstGeom prst="rect">
@@ -10225,7 +10495,7 @@
               <a:buNone/>
             </a:pPr>
             <a:r>
-              <a:rPr lang="en-US" sz="1200" b="1" dirty="0">
+              <a:rPr lang="en-US" sz="1400" b="1" dirty="0">
                 <a:solidFill>
                   <a:srgbClr val="213C80"/>
                 </a:solidFill>
@@ -10244,25 +10514,25 @@
               <a:buNone/>
             </a:pPr>
             <a:r>
-              <a:rPr lang="en-US" sz="1150" dirty="0">
+              <a:rPr lang="en-US" sz="1350" dirty="0">
                 <a:solidFill>
                   <a:srgbClr val="1F2937"/>
                 </a:solidFill>
               </a:rPr>
-              <a:t>Dedicated robotic team; few training centres</a:t>
+              <a:t>Few training centres</a:t>
             </a:r>
           </a:p>
         </p:txBody>
       </p:sp>
       <p:sp>
         <p:nvSpPr>
-          <p:cNvPr id="162" name="Challenge circle Access"/>
+          <p:cNvPr id="168" name="Challenge circle Access &amp; cost"/>
           <p:cNvSpPr txBox="1"/>
           <p:nvPr/>
         </p:nvSpPr>
         <p:spPr>
           <a:xfrm>
-            <a:off x="5774436" y="16987908"/>
+            <a:off x="5774436" y="17115174"/>
             <a:ext cx="512064" cy="512064"/>
           </a:xfrm>
           <a:prstGeom prst="ellipse">
@@ -10299,7 +10569,7 @@
       </p:sp>
       <p:pic>
         <p:nvPicPr>
-          <p:cNvPr id="163" name="Icon Access" descr="Access"/>
+          <p:cNvPr id="169" name="Icon Access &amp; cost" descr="Access &amp; cost"/>
           <p:cNvPicPr>
             <a:picLocks noChangeAspect="1"/>
           </p:cNvPicPr>
@@ -10313,7 +10583,7 @@
         </p:blipFill>
         <p:spPr>
           <a:xfrm>
-            <a:off x="5902452" y="17115924"/>
+            <a:off x="5902452" y="17243190"/>
             <a:ext cx="256032" cy="256032"/>
           </a:xfrm>
           <a:prstGeom prst="rect">
@@ -10323,13 +10593,13 @@
       </p:pic>
       <p:sp>
         <p:nvSpPr>
-          <p:cNvPr id="164" name="Challenge Access"/>
+          <p:cNvPr id="170" name="Challenge Access &amp; cost"/>
           <p:cNvSpPr txBox="1"/>
           <p:nvPr/>
         </p:nvSpPr>
         <p:spPr>
           <a:xfrm>
-            <a:off x="6432804" y="16951332"/>
+            <a:off x="6432804" y="17078598"/>
             <a:ext cx="4018788" cy="640080"/>
           </a:xfrm>
           <a:prstGeom prst="rect">
@@ -10356,12 +10626,12 @@
               <a:buNone/>
             </a:pPr>
             <a:r>
-              <a:rPr lang="en-US" sz="1200" b="1" dirty="0">
+              <a:rPr lang="en-US" sz="1400" b="1" dirty="0">
                 <a:solidFill>
                   <a:srgbClr val="213C80"/>
                 </a:solidFill>
               </a:rPr>
-              <a:t>Access</a:t>
+              <a:t>Access &amp; cost</a:t>
             </a:r>
           </a:p>
           <a:p>
@@ -10375,26 +10645,26 @@
               <a:buNone/>
             </a:pPr>
             <a:r>
-              <a:rPr lang="en-US" sz="1150" dirty="0">
+              <a:rPr lang="en-US" sz="1350" dirty="0">
                 <a:solidFill>
                   <a:srgbClr val="1F2937"/>
                 </a:solidFill>
               </a:rPr>
-              <a:t>High upfront cost; robots mostly in advanced economies</a:t>
+              <a:t>High upfront cost; unequal access</a:t>
             </a:r>
           </a:p>
         </p:txBody>
       </p:sp>
       <p:sp>
         <p:nvSpPr>
-          <p:cNvPr id="165" name="Conclusion box"/>
+          <p:cNvPr id="171" name="Conclusion box"/>
           <p:cNvSpPr txBox="1"/>
           <p:nvPr/>
         </p:nvSpPr>
         <p:spPr>
           <a:xfrm>
-            <a:off x="548640" y="17774292"/>
-            <a:ext cx="10040112" cy="1501260"/>
+            <a:off x="548640" y="17810118"/>
+            <a:ext cx="10040112" cy="1502010"/>
           </a:xfrm>
           <a:prstGeom prst="roundRect">
             <a:avLst>
@@ -10432,14 +10702,14 @@
       </p:sp>
       <p:sp>
         <p:nvSpPr>
-          <p:cNvPr id="166" name="Conclusion"/>
+          <p:cNvPr id="172" name="Conclusion"/>
           <p:cNvSpPr txBox="1"/>
           <p:nvPr/>
         </p:nvSpPr>
         <p:spPr>
           <a:xfrm>
-            <a:off x="822960" y="17774292"/>
-            <a:ext cx="8193024" cy="1501260"/>
+            <a:off x="822960" y="17810118"/>
+            <a:ext cx="8193024" cy="1502010"/>
           </a:xfrm>
           <a:prstGeom prst="rect">
             <a:avLst/>
@@ -10465,7 +10735,7 @@
               <a:buNone/>
             </a:pPr>
             <a:r>
-              <a:rPr lang="en-US" sz="1200" b="1" dirty="0">
+              <a:rPr lang="en-US" sz="1400" b="1" dirty="0">
                 <a:solidFill>
                   <a:srgbClr val="BB890B"/>
                 </a:solidFill>
@@ -10484,33 +10754,33 @@
               <a:buNone/>
             </a:pPr>
             <a:r>
-              <a:rPr lang="en-US" sz="1500" b="1" dirty="0">
+              <a:rPr lang="en-US" sz="1600" b="1" dirty="0">
                 <a:solidFill>
                   <a:srgbClr val="FFFFFF"/>
                 </a:solidFill>
               </a:rPr>
-              <a:t xml:space="preserve">RDP offers greater precision, better clinical outcomes and more spleen preservation than open and laparoscopic surgery, and is cost-effective. </a:t>
-            </a:r>
-            <a:r>
-              <a:rPr lang="en-US" sz="1500" dirty="0">
+              <a:t xml:space="preserve">RDP offers greater precision, better outcomes and more spleen preservation than open and laparoscopic surgery, and is cost-effective. </a:t>
+            </a:r>
+            <a:r>
+              <a:rPr lang="en-US" sz="1600" dirty="0">
                 <a:solidFill>
                   <a:srgbClr val="D6DCEB"/>
                 </a:solidFill>
               </a:rPr>
-              <a:t>Wider adoption depends on training and equitable access.</a:t>
+              <a:t>Wider adoption needs training and equitable access.</a:t>
             </a:r>
           </a:p>
         </p:txBody>
       </p:sp>
       <p:sp>
         <p:nvSpPr>
-          <p:cNvPr id="167" name="QR tile"/>
+          <p:cNvPr id="173" name="QR tile"/>
           <p:cNvSpPr txBox="1"/>
           <p:nvPr/>
         </p:nvSpPr>
         <p:spPr>
           <a:xfrm>
-            <a:off x="9427464" y="18012858"/>
+            <a:off x="9427464" y="18049059"/>
             <a:ext cx="1024128" cy="1024128"/>
           </a:xfrm>
           <a:prstGeom prst="roundRect">
@@ -10549,7 +10819,7 @@
       </p:sp>
       <p:pic>
         <p:nvPicPr>
-          <p:cNvPr id="168" name="QR code" descr="QR code linking to the full paper, doi.org/10.1016/j.lers.2025.02.001"/>
+          <p:cNvPr id="174" name="QR code" descr="QR code linking to the full paper, doi.org/10.1016/j.lers.2025.02.001"/>
           <p:cNvPicPr>
             <a:picLocks noChangeAspect="1"/>
           </p:cNvPicPr>
@@ -10563,7 +10833,7 @@
         </p:blipFill>
         <p:spPr>
           <a:xfrm>
-            <a:off x="9491472" y="18076866"/>
+            <a:off x="9491472" y="18113067"/>
             <a:ext cx="896112" cy="896112"/>
           </a:xfrm>
           <a:prstGeom prst="rect">

</xml_diff>

<commit_message>
Add University of Auckland and Health NZ logos to single-column poster header
Co-Authored-By: Claude Opus 5.5 <noreply@anthropic.com>
Claude-Session: https://claude.ai/code/session_01MfhLusbbFu3z4J6aTCZXt3
</commit_message>
<xml_diff>
--- a/poster/IHPBA2026_RDP_ePoster_single_column.pptx
+++ b/poster/IHPBA2026_RDP_ePoster_single_column.pptx
@@ -5870,8 +5870,8 @@
         </p:nvSpPr>
         <p:spPr>
           <a:xfrm>
-            <a:off x="4123944" y="347472"/>
-            <a:ext cx="6702552" cy="1307592"/>
+            <a:off x="4123944" y="274320"/>
+            <a:ext cx="6702552" cy="1143000"/>
           </a:xfrm>
         </p:spPr>
         <p:txBody>
@@ -5908,8 +5908,8 @@
         </p:nvSpPr>
         <p:spPr>
           <a:xfrm>
-            <a:off x="4123944" y="1783080"/>
-            <a:ext cx="6702552" cy="548640"/>
+            <a:off x="4123944" y="1481328"/>
+            <a:ext cx="6702552" cy="384048"/>
           </a:xfrm>
         </p:spPr>
         <p:txBody>
@@ -5974,8 +5974,8 @@
         </p:nvSpPr>
         <p:spPr>
           <a:xfrm>
-            <a:off x="4123944" y="2395728"/>
-            <a:ext cx="6702552" cy="1005840"/>
+            <a:off x="4123944" y="1901952"/>
+            <a:ext cx="6702552" cy="566928"/>
           </a:xfrm>
         </p:spPr>
         <p:txBody>
@@ -6025,7 +6025,145 @@
       </p:sp>
       <p:sp>
         <p:nvSpPr>
-          <p:cNvPr id="105" name="Stat ≈1 day"/>
+          <p:cNvPr id="104" name="UoA logo tile"/>
+          <p:cNvSpPr txBox="1"/>
+          <p:nvPr/>
+        </p:nvSpPr>
+        <p:spPr>
+          <a:xfrm>
+            <a:off x="4206240" y="2615184"/>
+            <a:ext cx="1893685" cy="896112"/>
+          </a:xfrm>
+          <a:prstGeom prst="roundRect">
+            <a:avLst>
+              <a:gd name="adj" fmla="val 8000"/>
+            </a:avLst>
+          </a:prstGeom>
+          <a:solidFill>
+            <a:srgbClr val="0B0C45"/>
+          </a:solidFill>
+          <a:ln>
+            <a:noFill/>
+          </a:ln>
+        </p:spPr>
+        <p:txBody>
+          <a:bodyPr wrap="square" lIns="0" tIns="0" rIns="0" bIns="0" anchor="t">
+            <a:noAutofit/>
+          </a:bodyPr>
+          <a:lstStyle/>
+          <a:p>
+            <a:pPr marL="0" indent="0">
+              <a:spcBef>
+                <a:spcPts val="0"/>
+              </a:spcBef>
+              <a:spcAft>
+                <a:spcPts val="0"/>
+              </a:spcAft>
+              <a:buNone/>
+            </a:pPr>
+            <a:r>
+              <a:rPr lang="en-US" dirty="0"/>
+              <a:t/>
+            </a:r>
+          </a:p>
+        </p:txBody>
+      </p:sp>
+      <p:pic>
+        <p:nvPicPr>
+          <p:cNvPr id="105" name="University of Auckland logo" descr="Waipapa Taumata Rau University of Auckland logo"/>
+          <p:cNvPicPr>
+            <a:picLocks noChangeAspect="1"/>
+          </p:cNvPicPr>
+          <p:nvPr/>
+        </p:nvPicPr>
+        <p:blipFill>
+          <a:blip r:embed="rIdImgUoA"/>
+          <a:stretch>
+            <a:fillRect/>
+          </a:stretch>
+        </p:blipFill>
+        <p:spPr>
+          <a:xfrm>
+            <a:off x="4251960" y="2660904"/>
+            <a:ext cx="1802245" cy="804672"/>
+          </a:xfrm>
+          <a:prstGeom prst="rect">
+            <a:avLst/>
+          </a:prstGeom>
+        </p:spPr>
+      </p:pic>
+      <p:sp>
+        <p:nvSpPr>
+          <p:cNvPr id="106" name="Health NZ logo tile"/>
+          <p:cNvSpPr txBox="1"/>
+          <p:nvPr/>
+        </p:nvSpPr>
+        <p:spPr>
+          <a:xfrm>
+            <a:off x="6328525" y="2615184"/>
+            <a:ext cx="2738351" cy="896112"/>
+          </a:xfrm>
+          <a:prstGeom prst="roundRect">
+            <a:avLst>
+              <a:gd name="adj" fmla="val 8000"/>
+            </a:avLst>
+          </a:prstGeom>
+          <a:solidFill>
+            <a:srgbClr val="FFFFFF"/>
+          </a:solidFill>
+          <a:ln>
+            <a:noFill/>
+          </a:ln>
+        </p:spPr>
+        <p:txBody>
+          <a:bodyPr wrap="square" lIns="0" tIns="0" rIns="0" bIns="0" anchor="t">
+            <a:noAutofit/>
+          </a:bodyPr>
+          <a:lstStyle/>
+          <a:p>
+            <a:pPr marL="0" indent="0">
+              <a:spcBef>
+                <a:spcPts val="0"/>
+              </a:spcBef>
+              <a:spcAft>
+                <a:spcPts val="0"/>
+              </a:spcAft>
+              <a:buNone/>
+            </a:pPr>
+            <a:r>
+              <a:rPr lang="en-US" dirty="0"/>
+              <a:t/>
+            </a:r>
+          </a:p>
+        </p:txBody>
+      </p:sp>
+      <p:pic>
+        <p:nvPicPr>
+          <p:cNvPr id="107" name="Health New Zealand logo" descr="Health New Zealand Te Whatu Ora logo"/>
+          <p:cNvPicPr>
+            <a:picLocks noChangeAspect="1"/>
+          </p:cNvPicPr>
+          <p:nvPr/>
+        </p:nvPicPr>
+        <p:blipFill>
+          <a:blip r:embed="rIdImgHNZ"/>
+          <a:stretch>
+            <a:fillRect/>
+          </a:stretch>
+        </p:blipFill>
+        <p:spPr>
+          <a:xfrm>
+            <a:off x="6511405" y="2834640"/>
+            <a:ext cx="2372591" cy="457200"/>
+          </a:xfrm>
+          <a:prstGeom prst="rect">
+            <a:avLst/>
+          </a:prstGeom>
+        </p:spPr>
+      </p:pic>
+      <p:sp>
+        <p:nvSpPr>
+          <p:cNvPr id="109" name="Stat ≈1 day"/>
           <p:cNvSpPr txBox="1"/>
           <p:nvPr/>
         </p:nvSpPr>
@@ -6093,7 +6231,7 @@
       </p:sp>
       <p:sp>
         <p:nvSpPr>
-          <p:cNvPr id="106" name="Stat 0%"/>
+          <p:cNvPr id="110" name="Stat 0%"/>
           <p:cNvSpPr txBox="1"/>
           <p:nvPr/>
         </p:nvSpPr>
@@ -6161,7 +6299,7 @@
       </p:sp>
       <p:sp>
         <p:nvSpPr>
-          <p:cNvPr id="107" name="Stat ≤ LDP"/>
+          <p:cNvPr id="111" name="Stat ≤ LDP"/>
           <p:cNvSpPr txBox="1"/>
           <p:nvPr/>
         </p:nvSpPr>
@@ -6229,7 +6367,7 @@
       </p:sp>
       <p:sp>
         <p:nvSpPr>
-          <p:cNvPr id="108" name="Stat +30 min"/>
+          <p:cNvPr id="112" name="Stat +30 min"/>
           <p:cNvSpPr txBox="1"/>
           <p:nvPr/>
         </p:nvSpPr>
@@ -6297,7 +6435,7 @@
       </p:sp>
       <p:sp>
         <p:nvSpPr>
-          <p:cNvPr id="109" name="Section 1 title bar"/>
+          <p:cNvPr id="113" name="Section 1 title bar"/>
           <p:cNvSpPr txBox="1"/>
           <p:nvPr/>
         </p:nvSpPr>
@@ -6342,7 +6480,7 @@
       </p:sp>
       <p:sp>
         <p:nvSpPr>
-          <p:cNvPr id="110" name="Section 1 number"/>
+          <p:cNvPr id="114" name="Section 1 number"/>
           <p:cNvSpPr txBox="1"/>
           <p:nvPr/>
         </p:nvSpPr>
@@ -6389,7 +6527,7 @@
       </p:sp>
       <p:sp>
         <p:nvSpPr>
-          <p:cNvPr id="111" name="Section 1 title"/>
+          <p:cNvPr id="115" name="Section 1 title"/>
           <p:cNvSpPr txBox="1"/>
           <p:nvPr/>
         </p:nvSpPr>
@@ -6434,7 +6572,7 @@
       </p:sp>
       <p:sp>
         <p:nvSpPr>
-          <p:cNvPr id="112" name="Background"/>
+          <p:cNvPr id="116" name="Background"/>
           <p:cNvSpPr txBox="1"/>
           <p:nvPr/>
         </p:nvSpPr>
@@ -6517,7 +6655,7 @@
       </p:sp>
       <p:sp>
         <p:nvSpPr>
-          <p:cNvPr id="113" name="Aim"/>
+          <p:cNvPr id="117" name="Aim"/>
           <p:cNvSpPr txBox="1"/>
           <p:nvPr/>
         </p:nvSpPr>
@@ -6570,7 +6708,7 @@
       </p:sp>
       <p:sp>
         <p:nvSpPr>
-          <p:cNvPr id="114" name="Section 2 title bar"/>
+          <p:cNvPr id="118" name="Section 2 title bar"/>
           <p:cNvSpPr txBox="1"/>
           <p:nvPr/>
         </p:nvSpPr>
@@ -6615,7 +6753,7 @@
       </p:sp>
       <p:sp>
         <p:nvSpPr>
-          <p:cNvPr id="115" name="Section 2 number"/>
+          <p:cNvPr id="119" name="Section 2 number"/>
           <p:cNvSpPr txBox="1"/>
           <p:nvPr/>
         </p:nvSpPr>
@@ -6662,7 +6800,7 @@
       </p:sp>
       <p:sp>
         <p:nvSpPr>
-          <p:cNvPr id="116" name="Section 2 title"/>
+          <p:cNvPr id="120" name="Section 2 title"/>
           <p:cNvSpPr txBox="1"/>
           <p:nvPr/>
         </p:nvSpPr>
@@ -6707,7 +6845,7 @@
       </p:sp>
       <p:sp>
         <p:nvSpPr>
-          <p:cNvPr id="117" name="Advantage circle 3D magnified"/>
+          <p:cNvPr id="121" name="Advantage circle 3D magnified"/>
           <p:cNvSpPr txBox="1"/>
           <p:nvPr/>
         </p:nvSpPr>
@@ -6750,7 +6888,7 @@
       </p:sp>
       <p:pic>
         <p:nvPicPr>
-          <p:cNvPr id="118" name="Icon 3D magnified" descr="3D magnified vision"/>
+          <p:cNvPr id="122" name="Icon 3D magnified" descr="3D magnified vision"/>
           <p:cNvPicPr>
             <a:picLocks noChangeAspect="1"/>
           </p:cNvPicPr>
@@ -6774,7 +6912,7 @@
       </p:pic>
       <p:sp>
         <p:nvSpPr>
-          <p:cNvPr id="119" name="Advantage 3D magnified"/>
+          <p:cNvPr id="123" name="Advantage 3D magnified"/>
           <p:cNvSpPr txBox="1"/>
           <p:nvPr/>
         </p:nvSpPr>
@@ -6838,7 +6976,7 @@
       </p:sp>
       <p:sp>
         <p:nvSpPr>
-          <p:cNvPr id="120" name="Advantage circle Tremor"/>
+          <p:cNvPr id="124" name="Advantage circle Tremor"/>
           <p:cNvSpPr txBox="1"/>
           <p:nvPr/>
         </p:nvSpPr>
@@ -6881,7 +7019,7 @@
       </p:sp>
       <p:pic>
         <p:nvPicPr>
-          <p:cNvPr id="121" name="Icon Tremor" descr="Tremor filtration"/>
+          <p:cNvPr id="125" name="Icon Tremor" descr="Tremor filtration"/>
           <p:cNvPicPr>
             <a:picLocks noChangeAspect="1"/>
           </p:cNvPicPr>
@@ -6905,7 +7043,7 @@
       </p:pic>
       <p:sp>
         <p:nvSpPr>
-          <p:cNvPr id="122" name="Advantage Tremor"/>
+          <p:cNvPr id="126" name="Advantage Tremor"/>
           <p:cNvSpPr txBox="1"/>
           <p:nvPr/>
         </p:nvSpPr>
@@ -6969,7 +7107,7 @@
       </p:sp>
       <p:sp>
         <p:nvSpPr>
-          <p:cNvPr id="123" name="Advantage circle Motion"/>
+          <p:cNvPr id="127" name="Advantage circle Motion"/>
           <p:cNvSpPr txBox="1"/>
           <p:nvPr/>
         </p:nvSpPr>
@@ -7012,7 +7150,7 @@
       </p:sp>
       <p:pic>
         <p:nvPicPr>
-          <p:cNvPr id="124" name="Icon Motion" descr="Motion scaling"/>
+          <p:cNvPr id="128" name="Icon Motion" descr="Motion scaling"/>
           <p:cNvPicPr>
             <a:picLocks noChangeAspect="1"/>
           </p:cNvPicPr>
@@ -7036,7 +7174,7 @@
       </p:pic>
       <p:sp>
         <p:nvSpPr>
-          <p:cNvPr id="125" name="Advantage Motion"/>
+          <p:cNvPr id="129" name="Advantage Motion"/>
           <p:cNvSpPr txBox="1"/>
           <p:nvPr/>
         </p:nvSpPr>
@@ -7100,7 +7238,7 @@
       </p:sp>
       <p:sp>
         <p:nvSpPr>
-          <p:cNvPr id="126" name="Advantage circle Wristed"/>
+          <p:cNvPr id="130" name="Advantage circle Wristed"/>
           <p:cNvSpPr txBox="1"/>
           <p:nvPr/>
         </p:nvSpPr>
@@ -7143,7 +7281,7 @@
       </p:sp>
       <p:pic>
         <p:nvPicPr>
-          <p:cNvPr id="127" name="Icon Wristed" descr="Wristed instruments"/>
+          <p:cNvPr id="131" name="Icon Wristed" descr="Wristed instruments"/>
           <p:cNvPicPr>
             <a:picLocks noChangeAspect="1"/>
           </p:cNvPicPr>
@@ -7167,7 +7305,7 @@
       </p:pic>
       <p:sp>
         <p:nvSpPr>
-          <p:cNvPr id="128" name="Advantage Wristed"/>
+          <p:cNvPr id="132" name="Advantage Wristed"/>
           <p:cNvSpPr txBox="1"/>
           <p:nvPr/>
         </p:nvSpPr>
@@ -7231,7 +7369,7 @@
       </p:sp>
       <p:sp>
         <p:nvSpPr>
-          <p:cNvPr id="129" name="Platforms note"/>
+          <p:cNvPr id="133" name="Platforms note"/>
           <p:cNvSpPr txBox="1"/>
           <p:nvPr/>
         </p:nvSpPr>
@@ -7284,7 +7422,7 @@
       </p:sp>
       <p:sp>
         <p:nvSpPr>
-          <p:cNvPr id="130" name="Section 3 title bar"/>
+          <p:cNvPr id="134" name="Section 3 title bar"/>
           <p:cNvSpPr txBox="1"/>
           <p:nvPr/>
         </p:nvSpPr>
@@ -7329,7 +7467,7 @@
       </p:sp>
       <p:sp>
         <p:nvSpPr>
-          <p:cNvPr id="131" name="Section 3 number"/>
+          <p:cNvPr id="135" name="Section 3 number"/>
           <p:cNvSpPr txBox="1"/>
           <p:nvPr/>
         </p:nvSpPr>
@@ -7376,7 +7514,7 @@
       </p:sp>
       <p:sp>
         <p:nvSpPr>
-          <p:cNvPr id="132" name="Section 3 title"/>
+          <p:cNvPr id="136" name="Section 3 title"/>
           <p:cNvSpPr txBox="1"/>
           <p:nvPr/>
         </p:nvSpPr>
@@ -7421,7 +7559,7 @@
       </p:sp>
       <p:sp>
         <p:nvSpPr>
-          <p:cNvPr id="133" name="Figure frame"/>
+          <p:cNvPr id="137" name="Figure frame"/>
           <p:cNvSpPr txBox="1"/>
           <p:nvPr/>
         </p:nvSpPr>
@@ -7466,7 +7604,7 @@
       </p:sp>
       <p:pic>
         <p:nvPicPr>
-          <p:cNvPr id="134" name="Figure 1" descr="Fig. 1 Port placement for robotic distal pancreatectomy"/>
+          <p:cNvPr id="138" name="Figure 1" descr="Fig. 1 Port placement for robotic distal pancreatectomy"/>
           <p:cNvPicPr>
             <a:picLocks noChangeAspect="1"/>
           </p:cNvPicPr>
@@ -7490,7 +7628,7 @@
       </p:pic>
       <p:sp>
         <p:nvSpPr>
-          <p:cNvPr id="135" name="Fig caption"/>
+          <p:cNvPr id="139" name="Fig caption"/>
           <p:cNvSpPr txBox="1"/>
           <p:nvPr/>
         </p:nvSpPr>
@@ -7539,7 +7677,7 @@
       </p:sp>
       <p:sp>
         <p:nvSpPr>
-          <p:cNvPr id="136" name="Step 1"/>
+          <p:cNvPr id="140" name="Step 1"/>
           <p:cNvSpPr txBox="1"/>
           <p:nvPr/>
         </p:nvSpPr>
@@ -7586,7 +7724,7 @@
       </p:sp>
       <p:sp>
         <p:nvSpPr>
-          <p:cNvPr id="137" name="Step 1 text"/>
+          <p:cNvPr id="141" name="Step 1 text"/>
           <p:cNvSpPr txBox="1"/>
           <p:nvPr/>
         </p:nvSpPr>
@@ -7650,7 +7788,7 @@
       </p:sp>
       <p:sp>
         <p:nvSpPr>
-          <p:cNvPr id="138" name="Step 2"/>
+          <p:cNvPr id="142" name="Step 2"/>
           <p:cNvSpPr txBox="1"/>
           <p:nvPr/>
         </p:nvSpPr>
@@ -7697,7 +7835,7 @@
       </p:sp>
       <p:sp>
         <p:nvSpPr>
-          <p:cNvPr id="139" name="Step 2 text"/>
+          <p:cNvPr id="143" name="Step 2 text"/>
           <p:cNvSpPr txBox="1"/>
           <p:nvPr/>
         </p:nvSpPr>
@@ -7761,7 +7899,7 @@
       </p:sp>
       <p:sp>
         <p:nvSpPr>
-          <p:cNvPr id="140" name="Step 3"/>
+          <p:cNvPr id="144" name="Step 3"/>
           <p:cNvSpPr txBox="1"/>
           <p:nvPr/>
         </p:nvSpPr>
@@ -7808,7 +7946,7 @@
       </p:sp>
       <p:sp>
         <p:nvSpPr>
-          <p:cNvPr id="141" name="Step 3 text"/>
+          <p:cNvPr id="145" name="Step 3 text"/>
           <p:cNvSpPr txBox="1"/>
           <p:nvPr/>
         </p:nvSpPr>
@@ -7872,7 +8010,7 @@
       </p:sp>
       <p:sp>
         <p:nvSpPr>
-          <p:cNvPr id="142" name="Step 4"/>
+          <p:cNvPr id="146" name="Step 4"/>
           <p:cNvSpPr txBox="1"/>
           <p:nvPr/>
         </p:nvSpPr>
@@ -7919,7 +8057,7 @@
       </p:sp>
       <p:sp>
         <p:nvSpPr>
-          <p:cNvPr id="143" name="Step 4 text"/>
+          <p:cNvPr id="147" name="Step 4 text"/>
           <p:cNvSpPr txBox="1"/>
           <p:nvPr/>
         </p:nvSpPr>
@@ -7983,7 +8121,7 @@
       </p:sp>
       <p:sp>
         <p:nvSpPr>
-          <p:cNvPr id="144" name="Step 5"/>
+          <p:cNvPr id="148" name="Step 5"/>
           <p:cNvSpPr txBox="1"/>
           <p:nvPr/>
         </p:nvSpPr>
@@ -8030,7 +8168,7 @@
       </p:sp>
       <p:sp>
         <p:nvSpPr>
-          <p:cNvPr id="145" name="Step 5 text"/>
+          <p:cNvPr id="149" name="Step 5 text"/>
           <p:cNvSpPr txBox="1"/>
           <p:nvPr/>
         </p:nvSpPr>
@@ -8094,7 +8232,7 @@
       </p:sp>
       <p:sp>
         <p:nvSpPr>
-          <p:cNvPr id="146" name="Spleen note"/>
+          <p:cNvPr id="150" name="Spleen note"/>
           <p:cNvSpPr txBox="1"/>
           <p:nvPr/>
         </p:nvSpPr>
@@ -8147,7 +8285,7 @@
       </p:sp>
       <p:sp>
         <p:nvSpPr>
-          <p:cNvPr id="147" name="Section 4 title bar"/>
+          <p:cNvPr id="151" name="Section 4 title bar"/>
           <p:cNvSpPr txBox="1"/>
           <p:nvPr/>
         </p:nvSpPr>
@@ -8192,7 +8330,7 @@
       </p:sp>
       <p:sp>
         <p:nvSpPr>
-          <p:cNvPr id="148" name="Section 4 number"/>
+          <p:cNvPr id="152" name="Section 4 number"/>
           <p:cNvSpPr txBox="1"/>
           <p:nvPr/>
         </p:nvSpPr>
@@ -8239,7 +8377,7 @@
       </p:sp>
       <p:sp>
         <p:nvSpPr>
-          <p:cNvPr id="149" name="Section 4 title"/>
+          <p:cNvPr id="153" name="Section 4 title"/>
           <p:cNvSpPr txBox="1"/>
           <p:nvPr/>
         </p:nvSpPr>
@@ -8284,7 +8422,7 @@
       </p:sp>
       <p:graphicFrame>
         <p:nvGraphicFramePr>
-          <p:cNvPr id="150" name="Outcomes table"/>
+          <p:cNvPr id="154" name="Outcomes table"/>
           <p:cNvGraphicFramePr>
             <a:graphicFrameLocks noGrp="1"/>
           </p:cNvGraphicFramePr>
@@ -9637,7 +9775,7 @@
       </p:graphicFrame>
       <p:sp>
         <p:nvSpPr>
-          <p:cNvPr id="151" name="Table key"/>
+          <p:cNvPr id="155" name="Table key"/>
           <p:cNvSpPr txBox="1"/>
           <p:nvPr/>
         </p:nvSpPr>
@@ -9722,7 +9860,7 @@
       </p:sp>
       <p:sp>
         <p:nvSpPr>
-          <p:cNvPr id="152" name="Section 5 title bar"/>
+          <p:cNvPr id="156" name="Section 5 title bar"/>
           <p:cNvSpPr txBox="1"/>
           <p:nvPr/>
         </p:nvSpPr>
@@ -9767,7 +9905,7 @@
       </p:sp>
       <p:sp>
         <p:nvSpPr>
-          <p:cNvPr id="153" name="Section 5 number"/>
+          <p:cNvPr id="157" name="Section 5 number"/>
           <p:cNvSpPr txBox="1"/>
           <p:nvPr/>
         </p:nvSpPr>
@@ -9814,7 +9952,7 @@
       </p:sp>
       <p:sp>
         <p:nvSpPr>
-          <p:cNvPr id="154" name="Section 5 title"/>
+          <p:cNvPr id="158" name="Section 5 title"/>
           <p:cNvSpPr txBox="1"/>
           <p:nvPr/>
         </p:nvSpPr>
@@ -9859,7 +9997,7 @@
       </p:sp>
       <p:sp>
         <p:nvSpPr>
-          <p:cNvPr id="155" name="Cost chip Operative cost"/>
+          <p:cNvPr id="159" name="Cost chip Operative cost"/>
           <p:cNvSpPr txBox="1"/>
           <p:nvPr/>
         </p:nvSpPr>
@@ -9927,7 +10065,7 @@
       </p:sp>
       <p:sp>
         <p:nvSpPr>
-          <p:cNvPr id="156" name="Cost chip Overall cost"/>
+          <p:cNvPr id="160" name="Cost chip Overall cost"/>
           <p:cNvSpPr txBox="1"/>
           <p:nvPr/>
         </p:nvSpPr>
@@ -9995,7 +10133,7 @@
       </p:sp>
       <p:sp>
         <p:nvSpPr>
-          <p:cNvPr id="157" name="Cost chip Quality of life"/>
+          <p:cNvPr id="161" name="Cost chip Quality of life"/>
           <p:cNvSpPr txBox="1"/>
           <p:nvPr/>
         </p:nvSpPr>
@@ -10063,7 +10201,7 @@
       </p:sp>
       <p:sp>
         <p:nvSpPr>
-          <p:cNvPr id="158" name="Cost bullets"/>
+          <p:cNvPr id="162" name="Cost bullets"/>
           <p:cNvSpPr txBox="1"/>
           <p:nvPr/>
         </p:nvSpPr>
@@ -10127,7 +10265,7 @@
       </p:sp>
       <p:sp>
         <p:nvSpPr>
-          <p:cNvPr id="159" name="Section 6 title bar"/>
+          <p:cNvPr id="163" name="Section 6 title bar"/>
           <p:cNvSpPr txBox="1"/>
           <p:nvPr/>
         </p:nvSpPr>
@@ -10172,7 +10310,7 @@
       </p:sp>
       <p:sp>
         <p:nvSpPr>
-          <p:cNvPr id="160" name="Section 6 number"/>
+          <p:cNvPr id="164" name="Section 6 number"/>
           <p:cNvSpPr txBox="1"/>
           <p:nvPr/>
         </p:nvSpPr>
@@ -10219,7 +10357,7 @@
       </p:sp>
       <p:sp>
         <p:nvSpPr>
-          <p:cNvPr id="161" name="Section 6 title"/>
+          <p:cNvPr id="165" name="Section 6 title"/>
           <p:cNvSpPr txBox="1"/>
           <p:nvPr/>
         </p:nvSpPr>
@@ -10264,7 +10402,7 @@
       </p:sp>
       <p:sp>
         <p:nvSpPr>
-          <p:cNvPr id="162" name="Challenge circle Operative time"/>
+          <p:cNvPr id="166" name="Challenge circle Operative time"/>
           <p:cNvSpPr txBox="1"/>
           <p:nvPr/>
         </p:nvSpPr>
@@ -10307,7 +10445,7 @@
       </p:sp>
       <p:pic>
         <p:nvPicPr>
-          <p:cNvPr id="163" name="Icon Operative time" descr="Operative time"/>
+          <p:cNvPr id="167" name="Icon Operative time" descr="Operative time"/>
           <p:cNvPicPr>
             <a:picLocks noChangeAspect="1"/>
           </p:cNvPicPr>
@@ -10331,7 +10469,7 @@
       </p:pic>
       <p:sp>
         <p:nvSpPr>
-          <p:cNvPr id="164" name="Challenge Operative time"/>
+          <p:cNvPr id="168" name="Challenge Operative time"/>
           <p:cNvSpPr txBox="1"/>
           <p:nvPr/>
         </p:nvSpPr>
@@ -10395,7 +10533,7 @@
       </p:sp>
       <p:sp>
         <p:nvSpPr>
-          <p:cNvPr id="165" name="Challenge circle Team &amp; training"/>
+          <p:cNvPr id="169" name="Challenge circle Team &amp; training"/>
           <p:cNvSpPr txBox="1"/>
           <p:nvPr/>
         </p:nvSpPr>
@@ -10438,7 +10576,7 @@
       </p:sp>
       <p:pic>
         <p:nvPicPr>
-          <p:cNvPr id="166" name="Icon Team &amp; training" descr="Team &amp; training"/>
+          <p:cNvPr id="170" name="Icon Team &amp; training" descr="Team &amp; training"/>
           <p:cNvPicPr>
             <a:picLocks noChangeAspect="1"/>
           </p:cNvPicPr>
@@ -10462,7 +10600,7 @@
       </p:pic>
       <p:sp>
         <p:nvSpPr>
-          <p:cNvPr id="167" name="Challenge Team &amp; training"/>
+          <p:cNvPr id="171" name="Challenge Team &amp; training"/>
           <p:cNvSpPr txBox="1"/>
           <p:nvPr/>
         </p:nvSpPr>
@@ -10526,7 +10664,7 @@
       </p:sp>
       <p:sp>
         <p:nvSpPr>
-          <p:cNvPr id="168" name="Challenge circle Access &amp; cost"/>
+          <p:cNvPr id="172" name="Challenge circle Access &amp; cost"/>
           <p:cNvSpPr txBox="1"/>
           <p:nvPr/>
         </p:nvSpPr>
@@ -10569,7 +10707,7 @@
       </p:sp>
       <p:pic>
         <p:nvPicPr>
-          <p:cNvPr id="169" name="Icon Access &amp; cost" descr="Access &amp; cost"/>
+          <p:cNvPr id="173" name="Icon Access &amp; cost" descr="Access &amp; cost"/>
           <p:cNvPicPr>
             <a:picLocks noChangeAspect="1"/>
           </p:cNvPicPr>
@@ -10593,7 +10731,7 @@
       </p:pic>
       <p:sp>
         <p:nvSpPr>
-          <p:cNvPr id="170" name="Challenge Access &amp; cost"/>
+          <p:cNvPr id="174" name="Challenge Access &amp; cost"/>
           <p:cNvSpPr txBox="1"/>
           <p:nvPr/>
         </p:nvSpPr>
@@ -10657,7 +10795,7 @@
       </p:sp>
       <p:sp>
         <p:nvSpPr>
-          <p:cNvPr id="171" name="Conclusion box"/>
+          <p:cNvPr id="175" name="Conclusion box"/>
           <p:cNvSpPr txBox="1"/>
           <p:nvPr/>
         </p:nvSpPr>
@@ -10702,7 +10840,7 @@
       </p:sp>
       <p:sp>
         <p:nvSpPr>
-          <p:cNvPr id="172" name="Conclusion"/>
+          <p:cNvPr id="176" name="Conclusion"/>
           <p:cNvSpPr txBox="1"/>
           <p:nvPr/>
         </p:nvSpPr>
@@ -10774,7 +10912,7 @@
       </p:sp>
       <p:sp>
         <p:nvSpPr>
-          <p:cNvPr id="173" name="QR tile"/>
+          <p:cNvPr id="177" name="QR tile"/>
           <p:cNvSpPr txBox="1"/>
           <p:nvPr/>
         </p:nvSpPr>
@@ -10819,7 +10957,7 @@
       </p:sp>
       <p:pic>
         <p:nvPicPr>
-          <p:cNvPr id="174" name="QR code" descr="QR code linking to the full paper, doi.org/10.1016/j.lers.2025.02.001"/>
+          <p:cNvPr id="178" name="QR code" descr="QR code linking to the full paper, doi.org/10.1016/j.lers.2025.02.001"/>
           <p:cNvPicPr>
             <a:picLocks noChangeAspect="1"/>
           </p:cNvPicPr>

</xml_diff>